<commit_message>
Apply Adobe color harmony rules
</commit_message>
<xml_diff>
--- a/docs/assets/infographic-seed-gallery.pptx
+++ b/docs/assets/infographic-seed-gallery.pptx
@@ -129,7 +129,7 @@
           <p:cNvPr id="2" name="제목 1">
             <a:extLst>
               <a:ext uri="{FF2B5EF4-FFF2-40B4-BE49-F238E27FC236}">
-                <a16:creationId xmlns:a16="http://schemas.microsoft.com/office/drawing/2014/main" id="{7A1E40C8-95D5-E37A-AAE4-A5DC461E48CD}"/>
+                <a16:creationId xmlns:a16="http://schemas.microsoft.com/office/drawing/2014/main" id="{AFC9275B-E053-C8AE-5CD4-405DFEECBB15}"/>
               </a:ext>
             </a:extLst>
           </p:cNvPr>
@@ -166,7 +166,7 @@
           <p:cNvPr id="3" name="부제목 2">
             <a:extLst>
               <a:ext uri="{FF2B5EF4-FFF2-40B4-BE49-F238E27FC236}">
-                <a16:creationId xmlns:a16="http://schemas.microsoft.com/office/drawing/2014/main" id="{F8608E62-6699-5D1E-543B-E2E9B07C2FA6}"/>
+                <a16:creationId xmlns:a16="http://schemas.microsoft.com/office/drawing/2014/main" id="{87E3C6B0-B908-B4E9-C337-1990D41CD154}"/>
               </a:ext>
             </a:extLst>
           </p:cNvPr>
@@ -236,7 +236,7 @@
           <p:cNvPr id="4" name="날짜 개체 틀 3">
             <a:extLst>
               <a:ext uri="{FF2B5EF4-FFF2-40B4-BE49-F238E27FC236}">
-                <a16:creationId xmlns:a16="http://schemas.microsoft.com/office/drawing/2014/main" id="{8160D882-BF0B-31AC-5944-E69FA304E459}"/>
+                <a16:creationId xmlns:a16="http://schemas.microsoft.com/office/drawing/2014/main" id="{1BD14F70-4CA9-CA47-19DF-895FB64669A2}"/>
               </a:ext>
             </a:extLst>
           </p:cNvPr>
@@ -252,7 +252,7 @@
           <a:bodyPr/>
           <a:lstStyle/>
           <a:p>
-            <a:fld id="{889E8D29-9AC6-4AA8-860A-C9485B2EE338}" type="datetimeFigureOut">
+            <a:fld id="{37A6BA30-5587-4442-AF77-A7B435B4C7C8}" type="datetimeFigureOut">
               <a:rPr lang="ko-KR" altLang="en-US" smtClean="0"/>
               <a:t>2026-06-19</a:t>
             </a:fld>
@@ -265,7 +265,7 @@
           <p:cNvPr id="5" name="바닥글 개체 틀 4">
             <a:extLst>
               <a:ext uri="{FF2B5EF4-FFF2-40B4-BE49-F238E27FC236}">
-                <a16:creationId xmlns:a16="http://schemas.microsoft.com/office/drawing/2014/main" id="{A5EB3755-3104-DE56-B3E0-B7D76079DB23}"/>
+                <a16:creationId xmlns:a16="http://schemas.microsoft.com/office/drawing/2014/main" id="{47680386-C879-CDE1-BE2F-B3626D4E23FD}"/>
               </a:ext>
             </a:extLst>
           </p:cNvPr>
@@ -290,7 +290,7 @@
           <p:cNvPr id="6" name="슬라이드 번호 개체 틀 5">
             <a:extLst>
               <a:ext uri="{FF2B5EF4-FFF2-40B4-BE49-F238E27FC236}">
-                <a16:creationId xmlns:a16="http://schemas.microsoft.com/office/drawing/2014/main" id="{5DBD65A4-B56A-0C79-F3D8-5B7211EF0D91}"/>
+                <a16:creationId xmlns:a16="http://schemas.microsoft.com/office/drawing/2014/main" id="{46D18647-E3FE-01AA-F35C-9D6AAC75C6B2}"/>
               </a:ext>
             </a:extLst>
           </p:cNvPr>
@@ -306,7 +306,7 @@
           <a:bodyPr/>
           <a:lstStyle/>
           <a:p>
-            <a:fld id="{E2A9101B-4DE9-41B7-92B7-E017EA92F55E}" type="slidenum">
+            <a:fld id="{D1DEAAE1-9523-4F91-9AA1-FE659F1DC52B}" type="slidenum">
               <a:rPr lang="ko-KR" altLang="en-US" smtClean="0"/>
               <a:t>‹#›</a:t>
             </a:fld>
@@ -317,7 +317,7 @@
     </p:spTree>
     <p:extLst>
       <p:ext uri="{BB962C8B-B14F-4D97-AF65-F5344CB8AC3E}">
-        <p14:creationId xmlns:p14="http://schemas.microsoft.com/office/powerpoint/2010/main" val="1741740731"/>
+        <p14:creationId xmlns:p14="http://schemas.microsoft.com/office/powerpoint/2010/main" val="2658028390"/>
       </p:ext>
     </p:extLst>
   </p:cSld>
@@ -349,7 +349,7 @@
           <p:cNvPr id="2" name="제목 1">
             <a:extLst>
               <a:ext uri="{FF2B5EF4-FFF2-40B4-BE49-F238E27FC236}">
-                <a16:creationId xmlns:a16="http://schemas.microsoft.com/office/drawing/2014/main" id="{DE007B13-531F-2DA0-0E99-22FAEBBB1C67}"/>
+                <a16:creationId xmlns:a16="http://schemas.microsoft.com/office/drawing/2014/main" id="{53CCBA7B-E095-E088-663A-E54EF243BF39}"/>
               </a:ext>
             </a:extLst>
           </p:cNvPr>
@@ -377,7 +377,7 @@
           <p:cNvPr id="3" name="세로 텍스트 개체 틀 2">
             <a:extLst>
               <a:ext uri="{FF2B5EF4-FFF2-40B4-BE49-F238E27FC236}">
-                <a16:creationId xmlns:a16="http://schemas.microsoft.com/office/drawing/2014/main" id="{607A88CE-CBFF-2207-FBBE-6B3F1DA861EE}"/>
+                <a16:creationId xmlns:a16="http://schemas.microsoft.com/office/drawing/2014/main" id="{266B73D9-2A24-494E-7CB9-A1FBEC6BAE49}"/>
               </a:ext>
             </a:extLst>
           </p:cNvPr>
@@ -434,7 +434,7 @@
           <p:cNvPr id="4" name="날짜 개체 틀 3">
             <a:extLst>
               <a:ext uri="{FF2B5EF4-FFF2-40B4-BE49-F238E27FC236}">
-                <a16:creationId xmlns:a16="http://schemas.microsoft.com/office/drawing/2014/main" id="{B4A78223-8AE0-95DF-8BAF-7F493090DE45}"/>
+                <a16:creationId xmlns:a16="http://schemas.microsoft.com/office/drawing/2014/main" id="{8ED0663D-E578-43D3-E2AD-5D4C4C1E01AD}"/>
               </a:ext>
             </a:extLst>
           </p:cNvPr>
@@ -450,7 +450,7 @@
           <a:bodyPr/>
           <a:lstStyle/>
           <a:p>
-            <a:fld id="{889E8D29-9AC6-4AA8-860A-C9485B2EE338}" type="datetimeFigureOut">
+            <a:fld id="{37A6BA30-5587-4442-AF77-A7B435B4C7C8}" type="datetimeFigureOut">
               <a:rPr lang="ko-KR" altLang="en-US" smtClean="0"/>
               <a:t>2026-06-19</a:t>
             </a:fld>
@@ -463,7 +463,7 @@
           <p:cNvPr id="5" name="바닥글 개체 틀 4">
             <a:extLst>
               <a:ext uri="{FF2B5EF4-FFF2-40B4-BE49-F238E27FC236}">
-                <a16:creationId xmlns:a16="http://schemas.microsoft.com/office/drawing/2014/main" id="{C75391FA-E273-D5D6-7AC1-A9A19E89A936}"/>
+                <a16:creationId xmlns:a16="http://schemas.microsoft.com/office/drawing/2014/main" id="{CB9CEC0A-652D-3B0C-BAF0-4297569131D0}"/>
               </a:ext>
             </a:extLst>
           </p:cNvPr>
@@ -488,7 +488,7 @@
           <p:cNvPr id="6" name="슬라이드 번호 개체 틀 5">
             <a:extLst>
               <a:ext uri="{FF2B5EF4-FFF2-40B4-BE49-F238E27FC236}">
-                <a16:creationId xmlns:a16="http://schemas.microsoft.com/office/drawing/2014/main" id="{7103CAE8-C4E9-4C25-97DA-65A8389FA489}"/>
+                <a16:creationId xmlns:a16="http://schemas.microsoft.com/office/drawing/2014/main" id="{AB7F0FB3-6A06-F1FF-197E-BC9BC08C42D9}"/>
               </a:ext>
             </a:extLst>
           </p:cNvPr>
@@ -504,7 +504,7 @@
           <a:bodyPr/>
           <a:lstStyle/>
           <a:p>
-            <a:fld id="{E2A9101B-4DE9-41B7-92B7-E017EA92F55E}" type="slidenum">
+            <a:fld id="{D1DEAAE1-9523-4F91-9AA1-FE659F1DC52B}" type="slidenum">
               <a:rPr lang="ko-KR" altLang="en-US" smtClean="0"/>
               <a:t>‹#›</a:t>
             </a:fld>
@@ -515,7 +515,7 @@
     </p:spTree>
     <p:extLst>
       <p:ext uri="{BB962C8B-B14F-4D97-AF65-F5344CB8AC3E}">
-        <p14:creationId xmlns:p14="http://schemas.microsoft.com/office/powerpoint/2010/main" val="2271292195"/>
+        <p14:creationId xmlns:p14="http://schemas.microsoft.com/office/powerpoint/2010/main" val="2360600143"/>
       </p:ext>
     </p:extLst>
   </p:cSld>
@@ -547,7 +547,7 @@
           <p:cNvPr id="2" name="세로 제목 1">
             <a:extLst>
               <a:ext uri="{FF2B5EF4-FFF2-40B4-BE49-F238E27FC236}">
-                <a16:creationId xmlns:a16="http://schemas.microsoft.com/office/drawing/2014/main" id="{3FC74CD6-E576-701A-E3FA-D7369BC2D9E1}"/>
+                <a16:creationId xmlns:a16="http://schemas.microsoft.com/office/drawing/2014/main" id="{BD948238-7B16-F32A-32D1-90033B4F3477}"/>
               </a:ext>
             </a:extLst>
           </p:cNvPr>
@@ -580,7 +580,7 @@
           <p:cNvPr id="3" name="세로 텍스트 개체 틀 2">
             <a:extLst>
               <a:ext uri="{FF2B5EF4-FFF2-40B4-BE49-F238E27FC236}">
-                <a16:creationId xmlns:a16="http://schemas.microsoft.com/office/drawing/2014/main" id="{919CAA6A-C198-254A-51A0-7080A0F174D9}"/>
+                <a16:creationId xmlns:a16="http://schemas.microsoft.com/office/drawing/2014/main" id="{72E3D09B-9C5C-A842-0B39-5060D9BB9D2C}"/>
               </a:ext>
             </a:extLst>
           </p:cNvPr>
@@ -642,7 +642,7 @@
           <p:cNvPr id="4" name="날짜 개체 틀 3">
             <a:extLst>
               <a:ext uri="{FF2B5EF4-FFF2-40B4-BE49-F238E27FC236}">
-                <a16:creationId xmlns:a16="http://schemas.microsoft.com/office/drawing/2014/main" id="{6C38D827-C5AD-98BB-FA0E-ED060A32E649}"/>
+                <a16:creationId xmlns:a16="http://schemas.microsoft.com/office/drawing/2014/main" id="{6709CBEC-CBB1-3ABB-847D-545D5398C28D}"/>
               </a:ext>
             </a:extLst>
           </p:cNvPr>
@@ -658,7 +658,7 @@
           <a:bodyPr/>
           <a:lstStyle/>
           <a:p>
-            <a:fld id="{889E8D29-9AC6-4AA8-860A-C9485B2EE338}" type="datetimeFigureOut">
+            <a:fld id="{37A6BA30-5587-4442-AF77-A7B435B4C7C8}" type="datetimeFigureOut">
               <a:rPr lang="ko-KR" altLang="en-US" smtClean="0"/>
               <a:t>2026-06-19</a:t>
             </a:fld>
@@ -671,7 +671,7 @@
           <p:cNvPr id="5" name="바닥글 개체 틀 4">
             <a:extLst>
               <a:ext uri="{FF2B5EF4-FFF2-40B4-BE49-F238E27FC236}">
-                <a16:creationId xmlns:a16="http://schemas.microsoft.com/office/drawing/2014/main" id="{0847B3D0-6142-CC0F-C8AE-86CE9F508D57}"/>
+                <a16:creationId xmlns:a16="http://schemas.microsoft.com/office/drawing/2014/main" id="{20D4665C-0207-75A2-0883-3B395B15F32C}"/>
               </a:ext>
             </a:extLst>
           </p:cNvPr>
@@ -696,7 +696,7 @@
           <p:cNvPr id="6" name="슬라이드 번호 개체 틀 5">
             <a:extLst>
               <a:ext uri="{FF2B5EF4-FFF2-40B4-BE49-F238E27FC236}">
-                <a16:creationId xmlns:a16="http://schemas.microsoft.com/office/drawing/2014/main" id="{F38CBB86-BD67-9BFA-698F-214E450604D1}"/>
+                <a16:creationId xmlns:a16="http://schemas.microsoft.com/office/drawing/2014/main" id="{6B5FFA6C-E561-F45E-8EF4-445AA3ABD9E6}"/>
               </a:ext>
             </a:extLst>
           </p:cNvPr>
@@ -712,7 +712,7 @@
           <a:bodyPr/>
           <a:lstStyle/>
           <a:p>
-            <a:fld id="{E2A9101B-4DE9-41B7-92B7-E017EA92F55E}" type="slidenum">
+            <a:fld id="{D1DEAAE1-9523-4F91-9AA1-FE659F1DC52B}" type="slidenum">
               <a:rPr lang="ko-KR" altLang="en-US" smtClean="0"/>
               <a:t>‹#›</a:t>
             </a:fld>
@@ -723,7 +723,7 @@
     </p:spTree>
     <p:extLst>
       <p:ext uri="{BB962C8B-B14F-4D97-AF65-F5344CB8AC3E}">
-        <p14:creationId xmlns:p14="http://schemas.microsoft.com/office/powerpoint/2010/main" val="3993447618"/>
+        <p14:creationId xmlns:p14="http://schemas.microsoft.com/office/powerpoint/2010/main" val="3997767716"/>
       </p:ext>
     </p:extLst>
   </p:cSld>
@@ -755,7 +755,7 @@
           <p:cNvPr id="2" name="제목 1">
             <a:extLst>
               <a:ext uri="{FF2B5EF4-FFF2-40B4-BE49-F238E27FC236}">
-                <a16:creationId xmlns:a16="http://schemas.microsoft.com/office/drawing/2014/main" id="{D1207B58-1A7E-FAD4-E894-11A19911D80A}"/>
+                <a16:creationId xmlns:a16="http://schemas.microsoft.com/office/drawing/2014/main" id="{5A734291-DC03-9D00-C1B5-5FFBF18013E4}"/>
               </a:ext>
             </a:extLst>
           </p:cNvPr>
@@ -783,7 +783,7 @@
           <p:cNvPr id="3" name="내용 개체 틀 2">
             <a:extLst>
               <a:ext uri="{FF2B5EF4-FFF2-40B4-BE49-F238E27FC236}">
-                <a16:creationId xmlns:a16="http://schemas.microsoft.com/office/drawing/2014/main" id="{BA18FCD5-C86E-FC70-637F-D8C263682BBD}"/>
+                <a16:creationId xmlns:a16="http://schemas.microsoft.com/office/drawing/2014/main" id="{F10DF0FD-CDCA-F54B-B44B-619EEFE52DDD}"/>
               </a:ext>
             </a:extLst>
           </p:cNvPr>
@@ -840,7 +840,7 @@
           <p:cNvPr id="4" name="날짜 개체 틀 3">
             <a:extLst>
               <a:ext uri="{FF2B5EF4-FFF2-40B4-BE49-F238E27FC236}">
-                <a16:creationId xmlns:a16="http://schemas.microsoft.com/office/drawing/2014/main" id="{6C601109-5C7E-BD87-2021-F38E30EE9B1B}"/>
+                <a16:creationId xmlns:a16="http://schemas.microsoft.com/office/drawing/2014/main" id="{535893D4-0035-31F0-E84C-7C34A93DCB19}"/>
               </a:ext>
             </a:extLst>
           </p:cNvPr>
@@ -856,7 +856,7 @@
           <a:bodyPr/>
           <a:lstStyle/>
           <a:p>
-            <a:fld id="{889E8D29-9AC6-4AA8-860A-C9485B2EE338}" type="datetimeFigureOut">
+            <a:fld id="{37A6BA30-5587-4442-AF77-A7B435B4C7C8}" type="datetimeFigureOut">
               <a:rPr lang="ko-KR" altLang="en-US" smtClean="0"/>
               <a:t>2026-06-19</a:t>
             </a:fld>
@@ -869,7 +869,7 @@
           <p:cNvPr id="5" name="바닥글 개체 틀 4">
             <a:extLst>
               <a:ext uri="{FF2B5EF4-FFF2-40B4-BE49-F238E27FC236}">
-                <a16:creationId xmlns:a16="http://schemas.microsoft.com/office/drawing/2014/main" id="{5ACB84AB-C9D9-9D6F-28B6-1E6AE4FA5F50}"/>
+                <a16:creationId xmlns:a16="http://schemas.microsoft.com/office/drawing/2014/main" id="{709223AE-DFC9-E5A5-4DB2-2C9951DC3380}"/>
               </a:ext>
             </a:extLst>
           </p:cNvPr>
@@ -894,7 +894,7 @@
           <p:cNvPr id="6" name="슬라이드 번호 개체 틀 5">
             <a:extLst>
               <a:ext uri="{FF2B5EF4-FFF2-40B4-BE49-F238E27FC236}">
-                <a16:creationId xmlns:a16="http://schemas.microsoft.com/office/drawing/2014/main" id="{6F8757E8-4D54-411E-D7C1-95250F81FE4F}"/>
+                <a16:creationId xmlns:a16="http://schemas.microsoft.com/office/drawing/2014/main" id="{78A75397-7286-7095-BC2F-B38B311E3695}"/>
               </a:ext>
             </a:extLst>
           </p:cNvPr>
@@ -910,7 +910,7 @@
           <a:bodyPr/>
           <a:lstStyle/>
           <a:p>
-            <a:fld id="{E2A9101B-4DE9-41B7-92B7-E017EA92F55E}" type="slidenum">
+            <a:fld id="{D1DEAAE1-9523-4F91-9AA1-FE659F1DC52B}" type="slidenum">
               <a:rPr lang="ko-KR" altLang="en-US" smtClean="0"/>
               <a:t>‹#›</a:t>
             </a:fld>
@@ -921,7 +921,7 @@
     </p:spTree>
     <p:extLst>
       <p:ext uri="{BB962C8B-B14F-4D97-AF65-F5344CB8AC3E}">
-        <p14:creationId xmlns:p14="http://schemas.microsoft.com/office/powerpoint/2010/main" val="834922319"/>
+        <p14:creationId xmlns:p14="http://schemas.microsoft.com/office/powerpoint/2010/main" val="1064622322"/>
       </p:ext>
     </p:extLst>
   </p:cSld>
@@ -953,7 +953,7 @@
           <p:cNvPr id="2" name="제목 1">
             <a:extLst>
               <a:ext uri="{FF2B5EF4-FFF2-40B4-BE49-F238E27FC236}">
-                <a16:creationId xmlns:a16="http://schemas.microsoft.com/office/drawing/2014/main" id="{9F5738C5-6B16-620D-80F6-A9990AB4AB3E}"/>
+                <a16:creationId xmlns:a16="http://schemas.microsoft.com/office/drawing/2014/main" id="{0C6CE29E-D438-D296-5C70-B57AD8D51893}"/>
               </a:ext>
             </a:extLst>
           </p:cNvPr>
@@ -990,7 +990,7 @@
           <p:cNvPr id="3" name="텍스트 개체 틀 2">
             <a:extLst>
               <a:ext uri="{FF2B5EF4-FFF2-40B4-BE49-F238E27FC236}">
-                <a16:creationId xmlns:a16="http://schemas.microsoft.com/office/drawing/2014/main" id="{DD4B4D8E-AB32-D306-936E-7D20D073755A}"/>
+                <a16:creationId xmlns:a16="http://schemas.microsoft.com/office/drawing/2014/main" id="{6E602F27-1075-14B5-0737-A85AD0CCC0AF}"/>
               </a:ext>
             </a:extLst>
           </p:cNvPr>
@@ -1115,7 +1115,7 @@
           <p:cNvPr id="4" name="날짜 개체 틀 3">
             <a:extLst>
               <a:ext uri="{FF2B5EF4-FFF2-40B4-BE49-F238E27FC236}">
-                <a16:creationId xmlns:a16="http://schemas.microsoft.com/office/drawing/2014/main" id="{671026A3-9471-086F-D544-DB81AABB87B3}"/>
+                <a16:creationId xmlns:a16="http://schemas.microsoft.com/office/drawing/2014/main" id="{63163966-36C6-5DF1-DD9D-20E4D7168004}"/>
               </a:ext>
             </a:extLst>
           </p:cNvPr>
@@ -1131,7 +1131,7 @@
           <a:bodyPr/>
           <a:lstStyle/>
           <a:p>
-            <a:fld id="{889E8D29-9AC6-4AA8-860A-C9485B2EE338}" type="datetimeFigureOut">
+            <a:fld id="{37A6BA30-5587-4442-AF77-A7B435B4C7C8}" type="datetimeFigureOut">
               <a:rPr lang="ko-KR" altLang="en-US" smtClean="0"/>
               <a:t>2026-06-19</a:t>
             </a:fld>
@@ -1144,7 +1144,7 @@
           <p:cNvPr id="5" name="바닥글 개체 틀 4">
             <a:extLst>
               <a:ext uri="{FF2B5EF4-FFF2-40B4-BE49-F238E27FC236}">
-                <a16:creationId xmlns:a16="http://schemas.microsoft.com/office/drawing/2014/main" id="{E88C07B6-97B8-3C54-9B4E-52000DBC85F4}"/>
+                <a16:creationId xmlns:a16="http://schemas.microsoft.com/office/drawing/2014/main" id="{32BF48D4-F04D-CE7D-6868-55AB1670FB1B}"/>
               </a:ext>
             </a:extLst>
           </p:cNvPr>
@@ -1169,7 +1169,7 @@
           <p:cNvPr id="6" name="슬라이드 번호 개체 틀 5">
             <a:extLst>
               <a:ext uri="{FF2B5EF4-FFF2-40B4-BE49-F238E27FC236}">
-                <a16:creationId xmlns:a16="http://schemas.microsoft.com/office/drawing/2014/main" id="{2C238A04-6C1D-F2D8-F82A-86439B9D9B88}"/>
+                <a16:creationId xmlns:a16="http://schemas.microsoft.com/office/drawing/2014/main" id="{EB96B1E6-6892-0A28-59C3-499383CCE5F1}"/>
               </a:ext>
             </a:extLst>
           </p:cNvPr>
@@ -1185,7 +1185,7 @@
           <a:bodyPr/>
           <a:lstStyle/>
           <a:p>
-            <a:fld id="{E2A9101B-4DE9-41B7-92B7-E017EA92F55E}" type="slidenum">
+            <a:fld id="{D1DEAAE1-9523-4F91-9AA1-FE659F1DC52B}" type="slidenum">
               <a:rPr lang="ko-KR" altLang="en-US" smtClean="0"/>
               <a:t>‹#›</a:t>
             </a:fld>
@@ -1196,7 +1196,7 @@
     </p:spTree>
     <p:extLst>
       <p:ext uri="{BB962C8B-B14F-4D97-AF65-F5344CB8AC3E}">
-        <p14:creationId xmlns:p14="http://schemas.microsoft.com/office/powerpoint/2010/main" val="1170063655"/>
+        <p14:creationId xmlns:p14="http://schemas.microsoft.com/office/powerpoint/2010/main" val="149861998"/>
       </p:ext>
     </p:extLst>
   </p:cSld>
@@ -1228,7 +1228,7 @@
           <p:cNvPr id="2" name="제목 1">
             <a:extLst>
               <a:ext uri="{FF2B5EF4-FFF2-40B4-BE49-F238E27FC236}">
-                <a16:creationId xmlns:a16="http://schemas.microsoft.com/office/drawing/2014/main" id="{0C1F397A-3BA0-EC94-0F89-F7723BE9EAA4}"/>
+                <a16:creationId xmlns:a16="http://schemas.microsoft.com/office/drawing/2014/main" id="{C19C8B7D-2272-E424-0F69-E49599D6FCAB}"/>
               </a:ext>
             </a:extLst>
           </p:cNvPr>
@@ -1256,7 +1256,7 @@
           <p:cNvPr id="3" name="내용 개체 틀 2">
             <a:extLst>
               <a:ext uri="{FF2B5EF4-FFF2-40B4-BE49-F238E27FC236}">
-                <a16:creationId xmlns:a16="http://schemas.microsoft.com/office/drawing/2014/main" id="{2A43433D-D887-D6C2-4098-0DD5F22904BD}"/>
+                <a16:creationId xmlns:a16="http://schemas.microsoft.com/office/drawing/2014/main" id="{97AC6775-0B77-95DA-5035-D12B89CDB2B4}"/>
               </a:ext>
             </a:extLst>
           </p:cNvPr>
@@ -1318,7 +1318,7 @@
           <p:cNvPr id="4" name="내용 개체 틀 3">
             <a:extLst>
               <a:ext uri="{FF2B5EF4-FFF2-40B4-BE49-F238E27FC236}">
-                <a16:creationId xmlns:a16="http://schemas.microsoft.com/office/drawing/2014/main" id="{995C7B1E-F83E-7A2E-75C9-E6674CC88372}"/>
+                <a16:creationId xmlns:a16="http://schemas.microsoft.com/office/drawing/2014/main" id="{E2F50498-65B2-A555-2D7E-B1FE90C16D46}"/>
               </a:ext>
             </a:extLst>
           </p:cNvPr>
@@ -1380,7 +1380,7 @@
           <p:cNvPr id="5" name="날짜 개체 틀 4">
             <a:extLst>
               <a:ext uri="{FF2B5EF4-FFF2-40B4-BE49-F238E27FC236}">
-                <a16:creationId xmlns:a16="http://schemas.microsoft.com/office/drawing/2014/main" id="{5AF02DE9-45B3-1727-D6EB-88C4ADC101DB}"/>
+                <a16:creationId xmlns:a16="http://schemas.microsoft.com/office/drawing/2014/main" id="{F4F61115-0871-C7BA-570F-3ED89E98D7D0}"/>
               </a:ext>
             </a:extLst>
           </p:cNvPr>
@@ -1396,7 +1396,7 @@
           <a:bodyPr/>
           <a:lstStyle/>
           <a:p>
-            <a:fld id="{889E8D29-9AC6-4AA8-860A-C9485B2EE338}" type="datetimeFigureOut">
+            <a:fld id="{37A6BA30-5587-4442-AF77-A7B435B4C7C8}" type="datetimeFigureOut">
               <a:rPr lang="ko-KR" altLang="en-US" smtClean="0"/>
               <a:t>2026-06-19</a:t>
             </a:fld>
@@ -1409,7 +1409,7 @@
           <p:cNvPr id="6" name="바닥글 개체 틀 5">
             <a:extLst>
               <a:ext uri="{FF2B5EF4-FFF2-40B4-BE49-F238E27FC236}">
-                <a16:creationId xmlns:a16="http://schemas.microsoft.com/office/drawing/2014/main" id="{B32B0567-7E8A-B04A-072E-4B275F4FB314}"/>
+                <a16:creationId xmlns:a16="http://schemas.microsoft.com/office/drawing/2014/main" id="{78147BA8-6E50-1009-A7E7-E1C2A044E747}"/>
               </a:ext>
             </a:extLst>
           </p:cNvPr>
@@ -1434,7 +1434,7 @@
           <p:cNvPr id="7" name="슬라이드 번호 개체 틀 6">
             <a:extLst>
               <a:ext uri="{FF2B5EF4-FFF2-40B4-BE49-F238E27FC236}">
-                <a16:creationId xmlns:a16="http://schemas.microsoft.com/office/drawing/2014/main" id="{F964C7F5-3BD9-BA63-47C1-606EB226122E}"/>
+                <a16:creationId xmlns:a16="http://schemas.microsoft.com/office/drawing/2014/main" id="{A8213329-9F92-E681-5F18-447D8334581F}"/>
               </a:ext>
             </a:extLst>
           </p:cNvPr>
@@ -1450,7 +1450,7 @@
           <a:bodyPr/>
           <a:lstStyle/>
           <a:p>
-            <a:fld id="{E2A9101B-4DE9-41B7-92B7-E017EA92F55E}" type="slidenum">
+            <a:fld id="{D1DEAAE1-9523-4F91-9AA1-FE659F1DC52B}" type="slidenum">
               <a:rPr lang="ko-KR" altLang="en-US" smtClean="0"/>
               <a:t>‹#›</a:t>
             </a:fld>
@@ -1461,7 +1461,7 @@
     </p:spTree>
     <p:extLst>
       <p:ext uri="{BB962C8B-B14F-4D97-AF65-F5344CB8AC3E}">
-        <p14:creationId xmlns:p14="http://schemas.microsoft.com/office/powerpoint/2010/main" val="106494898"/>
+        <p14:creationId xmlns:p14="http://schemas.microsoft.com/office/powerpoint/2010/main" val="3107413877"/>
       </p:ext>
     </p:extLst>
   </p:cSld>
@@ -1493,7 +1493,7 @@
           <p:cNvPr id="2" name="제목 1">
             <a:extLst>
               <a:ext uri="{FF2B5EF4-FFF2-40B4-BE49-F238E27FC236}">
-                <a16:creationId xmlns:a16="http://schemas.microsoft.com/office/drawing/2014/main" id="{76BFA894-7619-2E40-06CB-3B937CD116F1}"/>
+                <a16:creationId xmlns:a16="http://schemas.microsoft.com/office/drawing/2014/main" id="{2CE4859B-8E88-90FE-8836-F6164E407D39}"/>
               </a:ext>
             </a:extLst>
           </p:cNvPr>
@@ -1526,7 +1526,7 @@
           <p:cNvPr id="3" name="텍스트 개체 틀 2">
             <a:extLst>
               <a:ext uri="{FF2B5EF4-FFF2-40B4-BE49-F238E27FC236}">
-                <a16:creationId xmlns:a16="http://schemas.microsoft.com/office/drawing/2014/main" id="{3C13C6BF-31ED-8F1D-38AD-8F41831A8E28}"/>
+                <a16:creationId xmlns:a16="http://schemas.microsoft.com/office/drawing/2014/main" id="{EC368597-746F-F472-57B5-7C264905F6E6}"/>
               </a:ext>
             </a:extLst>
           </p:cNvPr>
@@ -1597,7 +1597,7 @@
           <p:cNvPr id="4" name="내용 개체 틀 3">
             <a:extLst>
               <a:ext uri="{FF2B5EF4-FFF2-40B4-BE49-F238E27FC236}">
-                <a16:creationId xmlns:a16="http://schemas.microsoft.com/office/drawing/2014/main" id="{5D07304C-25B5-B876-2AC4-E74813492DE7}"/>
+                <a16:creationId xmlns:a16="http://schemas.microsoft.com/office/drawing/2014/main" id="{79ADA2B1-20D9-89E4-DC00-62766F52E6F6}"/>
               </a:ext>
             </a:extLst>
           </p:cNvPr>
@@ -1659,7 +1659,7 @@
           <p:cNvPr id="5" name="텍스트 개체 틀 4">
             <a:extLst>
               <a:ext uri="{FF2B5EF4-FFF2-40B4-BE49-F238E27FC236}">
-                <a16:creationId xmlns:a16="http://schemas.microsoft.com/office/drawing/2014/main" id="{1421AF45-8CE0-2057-07AD-59F38ABBD595}"/>
+                <a16:creationId xmlns:a16="http://schemas.microsoft.com/office/drawing/2014/main" id="{005CB960-A95D-4216-8005-B3F0DE469012}"/>
               </a:ext>
             </a:extLst>
           </p:cNvPr>
@@ -1730,7 +1730,7 @@
           <p:cNvPr id="6" name="내용 개체 틀 5">
             <a:extLst>
               <a:ext uri="{FF2B5EF4-FFF2-40B4-BE49-F238E27FC236}">
-                <a16:creationId xmlns:a16="http://schemas.microsoft.com/office/drawing/2014/main" id="{075FF091-16E8-8326-1D3E-78C84A68F05A}"/>
+                <a16:creationId xmlns:a16="http://schemas.microsoft.com/office/drawing/2014/main" id="{930391A2-2901-883E-192D-4920CE3986BB}"/>
               </a:ext>
             </a:extLst>
           </p:cNvPr>
@@ -1792,7 +1792,7 @@
           <p:cNvPr id="7" name="날짜 개체 틀 6">
             <a:extLst>
               <a:ext uri="{FF2B5EF4-FFF2-40B4-BE49-F238E27FC236}">
-                <a16:creationId xmlns:a16="http://schemas.microsoft.com/office/drawing/2014/main" id="{F6FE4DA5-D1C9-E99F-7CAC-D1E665D0BCA1}"/>
+                <a16:creationId xmlns:a16="http://schemas.microsoft.com/office/drawing/2014/main" id="{F497CE13-D2D2-E71B-7C12-5D3E37CC026C}"/>
               </a:ext>
             </a:extLst>
           </p:cNvPr>
@@ -1808,7 +1808,7 @@
           <a:bodyPr/>
           <a:lstStyle/>
           <a:p>
-            <a:fld id="{889E8D29-9AC6-4AA8-860A-C9485B2EE338}" type="datetimeFigureOut">
+            <a:fld id="{37A6BA30-5587-4442-AF77-A7B435B4C7C8}" type="datetimeFigureOut">
               <a:rPr lang="ko-KR" altLang="en-US" smtClean="0"/>
               <a:t>2026-06-19</a:t>
             </a:fld>
@@ -1821,7 +1821,7 @@
           <p:cNvPr id="8" name="바닥글 개체 틀 7">
             <a:extLst>
               <a:ext uri="{FF2B5EF4-FFF2-40B4-BE49-F238E27FC236}">
-                <a16:creationId xmlns:a16="http://schemas.microsoft.com/office/drawing/2014/main" id="{CC10BA09-33B5-6698-D2C2-E2A30E5346CC}"/>
+                <a16:creationId xmlns:a16="http://schemas.microsoft.com/office/drawing/2014/main" id="{FDA3A9C4-C3DC-C350-6D36-B98EE964B37C}"/>
               </a:ext>
             </a:extLst>
           </p:cNvPr>
@@ -1846,7 +1846,7 @@
           <p:cNvPr id="9" name="슬라이드 번호 개체 틀 8">
             <a:extLst>
               <a:ext uri="{FF2B5EF4-FFF2-40B4-BE49-F238E27FC236}">
-                <a16:creationId xmlns:a16="http://schemas.microsoft.com/office/drawing/2014/main" id="{C8D6E82B-C711-879C-7A28-D43F2FBB7363}"/>
+                <a16:creationId xmlns:a16="http://schemas.microsoft.com/office/drawing/2014/main" id="{C2559D87-3B90-D9D5-0D0E-514FCD824A4B}"/>
               </a:ext>
             </a:extLst>
           </p:cNvPr>
@@ -1862,7 +1862,7 @@
           <a:bodyPr/>
           <a:lstStyle/>
           <a:p>
-            <a:fld id="{E2A9101B-4DE9-41B7-92B7-E017EA92F55E}" type="slidenum">
+            <a:fld id="{D1DEAAE1-9523-4F91-9AA1-FE659F1DC52B}" type="slidenum">
               <a:rPr lang="ko-KR" altLang="en-US" smtClean="0"/>
               <a:t>‹#›</a:t>
             </a:fld>
@@ -1873,7 +1873,7 @@
     </p:spTree>
     <p:extLst>
       <p:ext uri="{BB962C8B-B14F-4D97-AF65-F5344CB8AC3E}">
-        <p14:creationId xmlns:p14="http://schemas.microsoft.com/office/powerpoint/2010/main" val="3558325495"/>
+        <p14:creationId xmlns:p14="http://schemas.microsoft.com/office/powerpoint/2010/main" val="2129526242"/>
       </p:ext>
     </p:extLst>
   </p:cSld>
@@ -1905,7 +1905,7 @@
           <p:cNvPr id="2" name="제목 1">
             <a:extLst>
               <a:ext uri="{FF2B5EF4-FFF2-40B4-BE49-F238E27FC236}">
-                <a16:creationId xmlns:a16="http://schemas.microsoft.com/office/drawing/2014/main" id="{45BFE56C-B51E-AA53-77DE-E1819B5466DE}"/>
+                <a16:creationId xmlns:a16="http://schemas.microsoft.com/office/drawing/2014/main" id="{980C8D56-8746-A960-692A-FE92470A9E3E}"/>
               </a:ext>
             </a:extLst>
           </p:cNvPr>
@@ -1933,7 +1933,7 @@
           <p:cNvPr id="3" name="날짜 개체 틀 2">
             <a:extLst>
               <a:ext uri="{FF2B5EF4-FFF2-40B4-BE49-F238E27FC236}">
-                <a16:creationId xmlns:a16="http://schemas.microsoft.com/office/drawing/2014/main" id="{3CB2C402-31E4-34F3-B047-CA161B3C6278}"/>
+                <a16:creationId xmlns:a16="http://schemas.microsoft.com/office/drawing/2014/main" id="{46AA68BF-442C-825C-2033-E79DAB8670DC}"/>
               </a:ext>
             </a:extLst>
           </p:cNvPr>
@@ -1949,7 +1949,7 @@
           <a:bodyPr/>
           <a:lstStyle/>
           <a:p>
-            <a:fld id="{889E8D29-9AC6-4AA8-860A-C9485B2EE338}" type="datetimeFigureOut">
+            <a:fld id="{37A6BA30-5587-4442-AF77-A7B435B4C7C8}" type="datetimeFigureOut">
               <a:rPr lang="ko-KR" altLang="en-US" smtClean="0"/>
               <a:t>2026-06-19</a:t>
             </a:fld>
@@ -1962,7 +1962,7 @@
           <p:cNvPr id="4" name="바닥글 개체 틀 3">
             <a:extLst>
               <a:ext uri="{FF2B5EF4-FFF2-40B4-BE49-F238E27FC236}">
-                <a16:creationId xmlns:a16="http://schemas.microsoft.com/office/drawing/2014/main" id="{5E275C39-65D5-9A2B-4C47-BD6330D44536}"/>
+                <a16:creationId xmlns:a16="http://schemas.microsoft.com/office/drawing/2014/main" id="{A81A38BE-80A9-A3F7-DE7A-26621E560779}"/>
               </a:ext>
             </a:extLst>
           </p:cNvPr>
@@ -1987,7 +1987,7 @@
           <p:cNvPr id="5" name="슬라이드 번호 개체 틀 4">
             <a:extLst>
               <a:ext uri="{FF2B5EF4-FFF2-40B4-BE49-F238E27FC236}">
-                <a16:creationId xmlns:a16="http://schemas.microsoft.com/office/drawing/2014/main" id="{576FDDF5-DE0A-7F80-483C-1121FB8F64FE}"/>
+                <a16:creationId xmlns:a16="http://schemas.microsoft.com/office/drawing/2014/main" id="{A3A7352E-C9EC-0905-778B-E271C5E083F8}"/>
               </a:ext>
             </a:extLst>
           </p:cNvPr>
@@ -2003,7 +2003,7 @@
           <a:bodyPr/>
           <a:lstStyle/>
           <a:p>
-            <a:fld id="{E2A9101B-4DE9-41B7-92B7-E017EA92F55E}" type="slidenum">
+            <a:fld id="{D1DEAAE1-9523-4F91-9AA1-FE659F1DC52B}" type="slidenum">
               <a:rPr lang="ko-KR" altLang="en-US" smtClean="0"/>
               <a:t>‹#›</a:t>
             </a:fld>
@@ -2014,7 +2014,7 @@
     </p:spTree>
     <p:extLst>
       <p:ext uri="{BB962C8B-B14F-4D97-AF65-F5344CB8AC3E}">
-        <p14:creationId xmlns:p14="http://schemas.microsoft.com/office/powerpoint/2010/main" val="2407216594"/>
+        <p14:creationId xmlns:p14="http://schemas.microsoft.com/office/powerpoint/2010/main" val="186640407"/>
       </p:ext>
     </p:extLst>
   </p:cSld>
@@ -2046,7 +2046,7 @@
           <p:cNvPr id="2" name="날짜 개체 틀 1">
             <a:extLst>
               <a:ext uri="{FF2B5EF4-FFF2-40B4-BE49-F238E27FC236}">
-                <a16:creationId xmlns:a16="http://schemas.microsoft.com/office/drawing/2014/main" id="{9D9067E8-912F-E684-6DCF-1F8FD9D185C4}"/>
+                <a16:creationId xmlns:a16="http://schemas.microsoft.com/office/drawing/2014/main" id="{9635F1FA-2075-FB6D-268D-A8A5097B12D8}"/>
               </a:ext>
             </a:extLst>
           </p:cNvPr>
@@ -2062,7 +2062,7 @@
           <a:bodyPr/>
           <a:lstStyle/>
           <a:p>
-            <a:fld id="{889E8D29-9AC6-4AA8-860A-C9485B2EE338}" type="datetimeFigureOut">
+            <a:fld id="{37A6BA30-5587-4442-AF77-A7B435B4C7C8}" type="datetimeFigureOut">
               <a:rPr lang="ko-KR" altLang="en-US" smtClean="0"/>
               <a:t>2026-06-19</a:t>
             </a:fld>
@@ -2075,7 +2075,7 @@
           <p:cNvPr id="3" name="바닥글 개체 틀 2">
             <a:extLst>
               <a:ext uri="{FF2B5EF4-FFF2-40B4-BE49-F238E27FC236}">
-                <a16:creationId xmlns:a16="http://schemas.microsoft.com/office/drawing/2014/main" id="{E22C0EAA-BFBA-B5A3-0F51-DD9ED1A40347}"/>
+                <a16:creationId xmlns:a16="http://schemas.microsoft.com/office/drawing/2014/main" id="{A67EC4A0-BD51-3BDC-2959-1AF7B585B110}"/>
               </a:ext>
             </a:extLst>
           </p:cNvPr>
@@ -2100,7 +2100,7 @@
           <p:cNvPr id="4" name="슬라이드 번호 개체 틀 3">
             <a:extLst>
               <a:ext uri="{FF2B5EF4-FFF2-40B4-BE49-F238E27FC236}">
-                <a16:creationId xmlns:a16="http://schemas.microsoft.com/office/drawing/2014/main" id="{828F2D4B-E536-DE24-E506-9F06A667613B}"/>
+                <a16:creationId xmlns:a16="http://schemas.microsoft.com/office/drawing/2014/main" id="{91EAA5F1-8B02-D1FB-5FDC-196755027E84}"/>
               </a:ext>
             </a:extLst>
           </p:cNvPr>
@@ -2116,7 +2116,7 @@
           <a:bodyPr/>
           <a:lstStyle/>
           <a:p>
-            <a:fld id="{E2A9101B-4DE9-41B7-92B7-E017EA92F55E}" type="slidenum">
+            <a:fld id="{D1DEAAE1-9523-4F91-9AA1-FE659F1DC52B}" type="slidenum">
               <a:rPr lang="ko-KR" altLang="en-US" smtClean="0"/>
               <a:t>‹#›</a:t>
             </a:fld>
@@ -2127,7 +2127,7 @@
     </p:spTree>
     <p:extLst>
       <p:ext uri="{BB962C8B-B14F-4D97-AF65-F5344CB8AC3E}">
-        <p14:creationId xmlns:p14="http://schemas.microsoft.com/office/powerpoint/2010/main" val="2704538431"/>
+        <p14:creationId xmlns:p14="http://schemas.microsoft.com/office/powerpoint/2010/main" val="1651307502"/>
       </p:ext>
     </p:extLst>
   </p:cSld>
@@ -2159,7 +2159,7 @@
           <p:cNvPr id="2" name="제목 1">
             <a:extLst>
               <a:ext uri="{FF2B5EF4-FFF2-40B4-BE49-F238E27FC236}">
-                <a16:creationId xmlns:a16="http://schemas.microsoft.com/office/drawing/2014/main" id="{8C314C34-B73A-142F-A3DE-A9A3C0BD2FA1}"/>
+                <a16:creationId xmlns:a16="http://schemas.microsoft.com/office/drawing/2014/main" id="{81DF3020-173B-7C4A-F1D0-4901C3F15F12}"/>
               </a:ext>
             </a:extLst>
           </p:cNvPr>
@@ -2196,7 +2196,7 @@
           <p:cNvPr id="3" name="내용 개체 틀 2">
             <a:extLst>
               <a:ext uri="{FF2B5EF4-FFF2-40B4-BE49-F238E27FC236}">
-                <a16:creationId xmlns:a16="http://schemas.microsoft.com/office/drawing/2014/main" id="{BDA02796-AFCE-7026-14AA-81B7B4B01BF1}"/>
+                <a16:creationId xmlns:a16="http://schemas.microsoft.com/office/drawing/2014/main" id="{D057BEB0-56DB-B531-D251-02FA9264EC81}"/>
               </a:ext>
             </a:extLst>
           </p:cNvPr>
@@ -2286,7 +2286,7 @@
           <p:cNvPr id="4" name="텍스트 개체 틀 3">
             <a:extLst>
               <a:ext uri="{FF2B5EF4-FFF2-40B4-BE49-F238E27FC236}">
-                <a16:creationId xmlns:a16="http://schemas.microsoft.com/office/drawing/2014/main" id="{BDC08B72-A404-40C9-D7C7-27C3704D5AB9}"/>
+                <a16:creationId xmlns:a16="http://schemas.microsoft.com/office/drawing/2014/main" id="{7D66F40D-7176-67A5-1F5A-21FC5C54F5F2}"/>
               </a:ext>
             </a:extLst>
           </p:cNvPr>
@@ -2357,7 +2357,7 @@
           <p:cNvPr id="5" name="날짜 개체 틀 4">
             <a:extLst>
               <a:ext uri="{FF2B5EF4-FFF2-40B4-BE49-F238E27FC236}">
-                <a16:creationId xmlns:a16="http://schemas.microsoft.com/office/drawing/2014/main" id="{EE0A4BDC-4C4C-A688-7381-9F3326DBB642}"/>
+                <a16:creationId xmlns:a16="http://schemas.microsoft.com/office/drawing/2014/main" id="{858EB0C4-DA5B-9CD7-804C-B92ABEE768A2}"/>
               </a:ext>
             </a:extLst>
           </p:cNvPr>
@@ -2373,7 +2373,7 @@
           <a:bodyPr/>
           <a:lstStyle/>
           <a:p>
-            <a:fld id="{889E8D29-9AC6-4AA8-860A-C9485B2EE338}" type="datetimeFigureOut">
+            <a:fld id="{37A6BA30-5587-4442-AF77-A7B435B4C7C8}" type="datetimeFigureOut">
               <a:rPr lang="ko-KR" altLang="en-US" smtClean="0"/>
               <a:t>2026-06-19</a:t>
             </a:fld>
@@ -2386,7 +2386,7 @@
           <p:cNvPr id="6" name="바닥글 개체 틀 5">
             <a:extLst>
               <a:ext uri="{FF2B5EF4-FFF2-40B4-BE49-F238E27FC236}">
-                <a16:creationId xmlns:a16="http://schemas.microsoft.com/office/drawing/2014/main" id="{2C4A4AD1-AADB-4C71-DD57-9F8019618BC8}"/>
+                <a16:creationId xmlns:a16="http://schemas.microsoft.com/office/drawing/2014/main" id="{28978C9C-D6C9-4E0A-D421-86276812EF00}"/>
               </a:ext>
             </a:extLst>
           </p:cNvPr>
@@ -2411,7 +2411,7 @@
           <p:cNvPr id="7" name="슬라이드 번호 개체 틀 6">
             <a:extLst>
               <a:ext uri="{FF2B5EF4-FFF2-40B4-BE49-F238E27FC236}">
-                <a16:creationId xmlns:a16="http://schemas.microsoft.com/office/drawing/2014/main" id="{45F665C6-F5BC-8362-09E3-8ECFFCD37AA8}"/>
+                <a16:creationId xmlns:a16="http://schemas.microsoft.com/office/drawing/2014/main" id="{D4435DF5-B289-33FE-8848-C659AB4C2C8C}"/>
               </a:ext>
             </a:extLst>
           </p:cNvPr>
@@ -2427,7 +2427,7 @@
           <a:bodyPr/>
           <a:lstStyle/>
           <a:p>
-            <a:fld id="{E2A9101B-4DE9-41B7-92B7-E017EA92F55E}" type="slidenum">
+            <a:fld id="{D1DEAAE1-9523-4F91-9AA1-FE659F1DC52B}" type="slidenum">
               <a:rPr lang="ko-KR" altLang="en-US" smtClean="0"/>
               <a:t>‹#›</a:t>
             </a:fld>
@@ -2438,7 +2438,7 @@
     </p:spTree>
     <p:extLst>
       <p:ext uri="{BB962C8B-B14F-4D97-AF65-F5344CB8AC3E}">
-        <p14:creationId xmlns:p14="http://schemas.microsoft.com/office/powerpoint/2010/main" val="3256625135"/>
+        <p14:creationId xmlns:p14="http://schemas.microsoft.com/office/powerpoint/2010/main" val="330747519"/>
       </p:ext>
     </p:extLst>
   </p:cSld>
@@ -2470,7 +2470,7 @@
           <p:cNvPr id="2" name="제목 1">
             <a:extLst>
               <a:ext uri="{FF2B5EF4-FFF2-40B4-BE49-F238E27FC236}">
-                <a16:creationId xmlns:a16="http://schemas.microsoft.com/office/drawing/2014/main" id="{DF902267-EFC2-D466-C1A1-51BAE5F46F8B}"/>
+                <a16:creationId xmlns:a16="http://schemas.microsoft.com/office/drawing/2014/main" id="{AF4FDF3C-D5AB-D978-E17A-28CD2C41B009}"/>
               </a:ext>
             </a:extLst>
           </p:cNvPr>
@@ -2507,7 +2507,7 @@
           <p:cNvPr id="3" name="그림 개체 틀 2">
             <a:extLst>
               <a:ext uri="{FF2B5EF4-FFF2-40B4-BE49-F238E27FC236}">
-                <a16:creationId xmlns:a16="http://schemas.microsoft.com/office/drawing/2014/main" id="{77E0638C-67AC-9DEC-C33D-25B181AC6E0D}"/>
+                <a16:creationId xmlns:a16="http://schemas.microsoft.com/office/drawing/2014/main" id="{368C3EB7-F7FE-D849-BF43-172FDC04310A}"/>
               </a:ext>
             </a:extLst>
           </p:cNvPr>
@@ -2574,7 +2574,7 @@
           <p:cNvPr id="4" name="텍스트 개체 틀 3">
             <a:extLst>
               <a:ext uri="{FF2B5EF4-FFF2-40B4-BE49-F238E27FC236}">
-                <a16:creationId xmlns:a16="http://schemas.microsoft.com/office/drawing/2014/main" id="{63B43AB5-7E68-C1C0-5F02-BCFDD289FFEC}"/>
+                <a16:creationId xmlns:a16="http://schemas.microsoft.com/office/drawing/2014/main" id="{B1FAE160-2765-7AB6-B51F-8EFBBDEED85A}"/>
               </a:ext>
             </a:extLst>
           </p:cNvPr>
@@ -2645,7 +2645,7 @@
           <p:cNvPr id="5" name="날짜 개체 틀 4">
             <a:extLst>
               <a:ext uri="{FF2B5EF4-FFF2-40B4-BE49-F238E27FC236}">
-                <a16:creationId xmlns:a16="http://schemas.microsoft.com/office/drawing/2014/main" id="{9E82C8A1-3E98-8AA8-6785-B29B1F1BE23B}"/>
+                <a16:creationId xmlns:a16="http://schemas.microsoft.com/office/drawing/2014/main" id="{217D1A3C-351C-A1DC-4AE4-C08F2103A3A5}"/>
               </a:ext>
             </a:extLst>
           </p:cNvPr>
@@ -2661,7 +2661,7 @@
           <a:bodyPr/>
           <a:lstStyle/>
           <a:p>
-            <a:fld id="{889E8D29-9AC6-4AA8-860A-C9485B2EE338}" type="datetimeFigureOut">
+            <a:fld id="{37A6BA30-5587-4442-AF77-A7B435B4C7C8}" type="datetimeFigureOut">
               <a:rPr lang="ko-KR" altLang="en-US" smtClean="0"/>
               <a:t>2026-06-19</a:t>
             </a:fld>
@@ -2674,7 +2674,7 @@
           <p:cNvPr id="6" name="바닥글 개체 틀 5">
             <a:extLst>
               <a:ext uri="{FF2B5EF4-FFF2-40B4-BE49-F238E27FC236}">
-                <a16:creationId xmlns:a16="http://schemas.microsoft.com/office/drawing/2014/main" id="{B47DA439-98F1-6926-AAD9-DFFCB66A5EDE}"/>
+                <a16:creationId xmlns:a16="http://schemas.microsoft.com/office/drawing/2014/main" id="{BC97E207-5D4A-1A2E-9364-6D0D82CC8DA4}"/>
               </a:ext>
             </a:extLst>
           </p:cNvPr>
@@ -2699,7 +2699,7 @@
           <p:cNvPr id="7" name="슬라이드 번호 개체 틀 6">
             <a:extLst>
               <a:ext uri="{FF2B5EF4-FFF2-40B4-BE49-F238E27FC236}">
-                <a16:creationId xmlns:a16="http://schemas.microsoft.com/office/drawing/2014/main" id="{E3A25CDE-31F3-5452-6CE6-3AFE2BC693AF}"/>
+                <a16:creationId xmlns:a16="http://schemas.microsoft.com/office/drawing/2014/main" id="{100A9759-5D75-1EBF-01DC-9EC54FA6E530}"/>
               </a:ext>
             </a:extLst>
           </p:cNvPr>
@@ -2715,7 +2715,7 @@
           <a:bodyPr/>
           <a:lstStyle/>
           <a:p>
-            <a:fld id="{E2A9101B-4DE9-41B7-92B7-E017EA92F55E}" type="slidenum">
+            <a:fld id="{D1DEAAE1-9523-4F91-9AA1-FE659F1DC52B}" type="slidenum">
               <a:rPr lang="ko-KR" altLang="en-US" smtClean="0"/>
               <a:t>‹#›</a:t>
             </a:fld>
@@ -2726,7 +2726,7 @@
     </p:spTree>
     <p:extLst>
       <p:ext uri="{BB962C8B-B14F-4D97-AF65-F5344CB8AC3E}">
-        <p14:creationId xmlns:p14="http://schemas.microsoft.com/office/powerpoint/2010/main" val="2637755957"/>
+        <p14:creationId xmlns:p14="http://schemas.microsoft.com/office/powerpoint/2010/main" val="1120943280"/>
       </p:ext>
     </p:extLst>
   </p:cSld>
@@ -2763,7 +2763,7 @@
           <p:cNvPr id="2" name="제목 개체 틀 1">
             <a:extLst>
               <a:ext uri="{FF2B5EF4-FFF2-40B4-BE49-F238E27FC236}">
-                <a16:creationId xmlns:a16="http://schemas.microsoft.com/office/drawing/2014/main" id="{A6D4E7E3-1E25-5EB2-38E2-15DE73148EA4}"/>
+                <a16:creationId xmlns:a16="http://schemas.microsoft.com/office/drawing/2014/main" id="{9EB43992-E9C2-672A-B227-8696D5234AD2}"/>
               </a:ext>
             </a:extLst>
           </p:cNvPr>
@@ -2801,7 +2801,7 @@
           <p:cNvPr id="3" name="텍스트 개체 틀 2">
             <a:extLst>
               <a:ext uri="{FF2B5EF4-FFF2-40B4-BE49-F238E27FC236}">
-                <a16:creationId xmlns:a16="http://schemas.microsoft.com/office/drawing/2014/main" id="{F1263AAA-8D2D-C1F0-5274-CFFD41BF292C}"/>
+                <a16:creationId xmlns:a16="http://schemas.microsoft.com/office/drawing/2014/main" id="{B0B24729-3D38-D9B8-8501-5A807B999D0A}"/>
               </a:ext>
             </a:extLst>
           </p:cNvPr>
@@ -2868,7 +2868,7 @@
           <p:cNvPr id="4" name="날짜 개체 틀 3">
             <a:extLst>
               <a:ext uri="{FF2B5EF4-FFF2-40B4-BE49-F238E27FC236}">
-                <a16:creationId xmlns:a16="http://schemas.microsoft.com/office/drawing/2014/main" id="{DB756A2E-5BDC-425E-4F30-BECA5DA91935}"/>
+                <a16:creationId xmlns:a16="http://schemas.microsoft.com/office/drawing/2014/main" id="{0A6BD229-831E-3ECA-6158-F95BCE3514CC}"/>
               </a:ext>
             </a:extLst>
           </p:cNvPr>
@@ -2902,7 +2902,7 @@
             </a:lvl1pPr>
           </a:lstStyle>
           <a:p>
-            <a:fld id="{889E8D29-9AC6-4AA8-860A-C9485B2EE338}" type="datetimeFigureOut">
+            <a:fld id="{37A6BA30-5587-4442-AF77-A7B435B4C7C8}" type="datetimeFigureOut">
               <a:rPr lang="ko-KR" altLang="en-US" smtClean="0"/>
               <a:t>2026-06-19</a:t>
             </a:fld>
@@ -2915,7 +2915,7 @@
           <p:cNvPr id="5" name="바닥글 개체 틀 4">
             <a:extLst>
               <a:ext uri="{FF2B5EF4-FFF2-40B4-BE49-F238E27FC236}">
-                <a16:creationId xmlns:a16="http://schemas.microsoft.com/office/drawing/2014/main" id="{2A2121A7-BF1F-7706-FEBF-9F5CA038AED8}"/>
+                <a16:creationId xmlns:a16="http://schemas.microsoft.com/office/drawing/2014/main" id="{3FE6A4C6-536B-CF6C-AE80-3B8825B16AA3}"/>
               </a:ext>
             </a:extLst>
           </p:cNvPr>
@@ -2958,7 +2958,7 @@
           <p:cNvPr id="6" name="슬라이드 번호 개체 틀 5">
             <a:extLst>
               <a:ext uri="{FF2B5EF4-FFF2-40B4-BE49-F238E27FC236}">
-                <a16:creationId xmlns:a16="http://schemas.microsoft.com/office/drawing/2014/main" id="{44505381-E41E-D6F4-2333-62D341CA60C7}"/>
+                <a16:creationId xmlns:a16="http://schemas.microsoft.com/office/drawing/2014/main" id="{3A36A527-F2C3-C4F7-9152-3353B5BB14F2}"/>
               </a:ext>
             </a:extLst>
           </p:cNvPr>
@@ -2992,7 +2992,7 @@
             </a:lvl1pPr>
           </a:lstStyle>
           <a:p>
-            <a:fld id="{E2A9101B-4DE9-41B7-92B7-E017EA92F55E}" type="slidenum">
+            <a:fld id="{D1DEAAE1-9523-4F91-9AA1-FE659F1DC52B}" type="slidenum">
               <a:rPr lang="ko-KR" altLang="en-US" smtClean="0"/>
               <a:t>‹#›</a:t>
             </a:fld>
@@ -3003,7 +3003,7 @@
     </p:spTree>
     <p:extLst>
       <p:ext uri="{BB962C8B-B14F-4D97-AF65-F5344CB8AC3E}">
-        <p14:creationId xmlns:p14="http://schemas.microsoft.com/office/powerpoint/2010/main" val="1680678535"/>
+        <p14:creationId xmlns:p14="http://schemas.microsoft.com/office/powerpoint/2010/main" val="4178311776"/>
       </p:ext>
     </p:extLst>
   </p:cSld>
@@ -3326,7 +3326,7 @@
           <p:cNvPr id="3" name="그래픽 2">
             <a:extLst>
               <a:ext uri="{FF2B5EF4-FFF2-40B4-BE49-F238E27FC236}">
-                <a16:creationId xmlns:a16="http://schemas.microsoft.com/office/drawing/2014/main" id="{E76A1812-19F2-B746-6F18-C2CB0499C852}"/>
+                <a16:creationId xmlns:a16="http://schemas.microsoft.com/office/drawing/2014/main" id="{8666F243-5E7E-E063-7690-285F5A1CFB72}"/>
               </a:ext>
             </a:extLst>
           </p:cNvPr>
@@ -3360,7 +3360,7 @@
     </p:spTree>
     <p:extLst>
       <p:ext uri="{BB962C8B-B14F-4D97-AF65-F5344CB8AC3E}">
-        <p14:creationId xmlns:p14="http://schemas.microsoft.com/office/powerpoint/2010/main" val="2050486254"/>
+        <p14:creationId xmlns:p14="http://schemas.microsoft.com/office/powerpoint/2010/main" val="604552231"/>
       </p:ext>
     </p:extLst>
   </p:cSld>

</xml_diff>

<commit_message>
Prepare MDPR skill release artifacts
</commit_message>
<xml_diff>
--- a/docs/assets/infographic-seed-gallery.pptx
+++ b/docs/assets/infographic-seed-gallery.pptx
@@ -129,7 +129,7 @@
           <p:cNvPr id="2" name="제목 1">
             <a:extLst>
               <a:ext uri="{FF2B5EF4-FFF2-40B4-BE49-F238E27FC236}">
-                <a16:creationId xmlns:a16="http://schemas.microsoft.com/office/drawing/2014/main" id="{AFC9275B-E053-C8AE-5CD4-405DFEECBB15}"/>
+                <a16:creationId xmlns:a16="http://schemas.microsoft.com/office/drawing/2014/main" id="{BF808252-9F41-AA7F-BC7E-F1CFD733A803}"/>
               </a:ext>
             </a:extLst>
           </p:cNvPr>
@@ -166,7 +166,7 @@
           <p:cNvPr id="3" name="부제목 2">
             <a:extLst>
               <a:ext uri="{FF2B5EF4-FFF2-40B4-BE49-F238E27FC236}">
-                <a16:creationId xmlns:a16="http://schemas.microsoft.com/office/drawing/2014/main" id="{87E3C6B0-B908-B4E9-C337-1990D41CD154}"/>
+                <a16:creationId xmlns:a16="http://schemas.microsoft.com/office/drawing/2014/main" id="{14AF7F92-B0C7-452E-F225-9827294CF50D}"/>
               </a:ext>
             </a:extLst>
           </p:cNvPr>
@@ -236,7 +236,7 @@
           <p:cNvPr id="4" name="날짜 개체 틀 3">
             <a:extLst>
               <a:ext uri="{FF2B5EF4-FFF2-40B4-BE49-F238E27FC236}">
-                <a16:creationId xmlns:a16="http://schemas.microsoft.com/office/drawing/2014/main" id="{1BD14F70-4CA9-CA47-19DF-895FB64669A2}"/>
+                <a16:creationId xmlns:a16="http://schemas.microsoft.com/office/drawing/2014/main" id="{98492FD4-9DB7-E864-2730-B2D9A6CB3265}"/>
               </a:ext>
             </a:extLst>
           </p:cNvPr>
@@ -252,9 +252,9 @@
           <a:bodyPr/>
           <a:lstStyle/>
           <a:p>
-            <a:fld id="{37A6BA30-5587-4442-AF77-A7B435B4C7C8}" type="datetimeFigureOut">
+            <a:fld id="{43E4A4A8-B4B0-45DC-B516-12D2C29E74C6}" type="datetimeFigureOut">
               <a:rPr lang="ko-KR" altLang="en-US" smtClean="0"/>
-              <a:t>2026-06-19</a:t>
+              <a:t>2026-06-20</a:t>
             </a:fld>
             <a:endParaRPr lang="ko-KR" altLang="en-US"/>
           </a:p>
@@ -265,7 +265,7 @@
           <p:cNvPr id="5" name="바닥글 개체 틀 4">
             <a:extLst>
               <a:ext uri="{FF2B5EF4-FFF2-40B4-BE49-F238E27FC236}">
-                <a16:creationId xmlns:a16="http://schemas.microsoft.com/office/drawing/2014/main" id="{47680386-C879-CDE1-BE2F-B3626D4E23FD}"/>
+                <a16:creationId xmlns:a16="http://schemas.microsoft.com/office/drawing/2014/main" id="{CB6179B8-3C8B-AB43-37CB-7489EF50B60D}"/>
               </a:ext>
             </a:extLst>
           </p:cNvPr>
@@ -290,7 +290,7 @@
           <p:cNvPr id="6" name="슬라이드 번호 개체 틀 5">
             <a:extLst>
               <a:ext uri="{FF2B5EF4-FFF2-40B4-BE49-F238E27FC236}">
-                <a16:creationId xmlns:a16="http://schemas.microsoft.com/office/drawing/2014/main" id="{46D18647-E3FE-01AA-F35C-9D6AAC75C6B2}"/>
+                <a16:creationId xmlns:a16="http://schemas.microsoft.com/office/drawing/2014/main" id="{98256017-3783-5F68-CEFE-E0BC6E63FB61}"/>
               </a:ext>
             </a:extLst>
           </p:cNvPr>
@@ -306,7 +306,7 @@
           <a:bodyPr/>
           <a:lstStyle/>
           <a:p>
-            <a:fld id="{D1DEAAE1-9523-4F91-9AA1-FE659F1DC52B}" type="slidenum">
+            <a:fld id="{DA293E9B-4C70-475B-B5B5-C6D1CDF11403}" type="slidenum">
               <a:rPr lang="ko-KR" altLang="en-US" smtClean="0"/>
               <a:t>‹#›</a:t>
             </a:fld>
@@ -317,7 +317,7 @@
     </p:spTree>
     <p:extLst>
       <p:ext uri="{BB962C8B-B14F-4D97-AF65-F5344CB8AC3E}">
-        <p14:creationId xmlns:p14="http://schemas.microsoft.com/office/powerpoint/2010/main" val="2658028390"/>
+        <p14:creationId xmlns:p14="http://schemas.microsoft.com/office/powerpoint/2010/main" val="1251835415"/>
       </p:ext>
     </p:extLst>
   </p:cSld>
@@ -349,7 +349,7 @@
           <p:cNvPr id="2" name="제목 1">
             <a:extLst>
               <a:ext uri="{FF2B5EF4-FFF2-40B4-BE49-F238E27FC236}">
-                <a16:creationId xmlns:a16="http://schemas.microsoft.com/office/drawing/2014/main" id="{53CCBA7B-E095-E088-663A-E54EF243BF39}"/>
+                <a16:creationId xmlns:a16="http://schemas.microsoft.com/office/drawing/2014/main" id="{7A03111E-808B-3FEF-5601-BD6C49630FEC}"/>
               </a:ext>
             </a:extLst>
           </p:cNvPr>
@@ -377,7 +377,7 @@
           <p:cNvPr id="3" name="세로 텍스트 개체 틀 2">
             <a:extLst>
               <a:ext uri="{FF2B5EF4-FFF2-40B4-BE49-F238E27FC236}">
-                <a16:creationId xmlns:a16="http://schemas.microsoft.com/office/drawing/2014/main" id="{266B73D9-2A24-494E-7CB9-A1FBEC6BAE49}"/>
+                <a16:creationId xmlns:a16="http://schemas.microsoft.com/office/drawing/2014/main" id="{05F6DCD3-54B4-0B60-9E06-F8FCAF07760A}"/>
               </a:ext>
             </a:extLst>
           </p:cNvPr>
@@ -434,7 +434,7 @@
           <p:cNvPr id="4" name="날짜 개체 틀 3">
             <a:extLst>
               <a:ext uri="{FF2B5EF4-FFF2-40B4-BE49-F238E27FC236}">
-                <a16:creationId xmlns:a16="http://schemas.microsoft.com/office/drawing/2014/main" id="{8ED0663D-E578-43D3-E2AD-5D4C4C1E01AD}"/>
+                <a16:creationId xmlns:a16="http://schemas.microsoft.com/office/drawing/2014/main" id="{F80A89B7-9A61-63F1-081E-A491944C2B64}"/>
               </a:ext>
             </a:extLst>
           </p:cNvPr>
@@ -450,9 +450,9 @@
           <a:bodyPr/>
           <a:lstStyle/>
           <a:p>
-            <a:fld id="{37A6BA30-5587-4442-AF77-A7B435B4C7C8}" type="datetimeFigureOut">
+            <a:fld id="{43E4A4A8-B4B0-45DC-B516-12D2C29E74C6}" type="datetimeFigureOut">
               <a:rPr lang="ko-KR" altLang="en-US" smtClean="0"/>
-              <a:t>2026-06-19</a:t>
+              <a:t>2026-06-20</a:t>
             </a:fld>
             <a:endParaRPr lang="ko-KR" altLang="en-US"/>
           </a:p>
@@ -463,7 +463,7 @@
           <p:cNvPr id="5" name="바닥글 개체 틀 4">
             <a:extLst>
               <a:ext uri="{FF2B5EF4-FFF2-40B4-BE49-F238E27FC236}">
-                <a16:creationId xmlns:a16="http://schemas.microsoft.com/office/drawing/2014/main" id="{CB9CEC0A-652D-3B0C-BAF0-4297569131D0}"/>
+                <a16:creationId xmlns:a16="http://schemas.microsoft.com/office/drawing/2014/main" id="{51C99ECC-A5C8-DC6D-E806-C8D82F5BF93C}"/>
               </a:ext>
             </a:extLst>
           </p:cNvPr>
@@ -488,7 +488,7 @@
           <p:cNvPr id="6" name="슬라이드 번호 개체 틀 5">
             <a:extLst>
               <a:ext uri="{FF2B5EF4-FFF2-40B4-BE49-F238E27FC236}">
-                <a16:creationId xmlns:a16="http://schemas.microsoft.com/office/drawing/2014/main" id="{AB7F0FB3-6A06-F1FF-197E-BC9BC08C42D9}"/>
+                <a16:creationId xmlns:a16="http://schemas.microsoft.com/office/drawing/2014/main" id="{11A169AB-B5C5-44A3-B759-753907C57F4F}"/>
               </a:ext>
             </a:extLst>
           </p:cNvPr>
@@ -504,7 +504,7 @@
           <a:bodyPr/>
           <a:lstStyle/>
           <a:p>
-            <a:fld id="{D1DEAAE1-9523-4F91-9AA1-FE659F1DC52B}" type="slidenum">
+            <a:fld id="{DA293E9B-4C70-475B-B5B5-C6D1CDF11403}" type="slidenum">
               <a:rPr lang="ko-KR" altLang="en-US" smtClean="0"/>
               <a:t>‹#›</a:t>
             </a:fld>
@@ -515,7 +515,7 @@
     </p:spTree>
     <p:extLst>
       <p:ext uri="{BB962C8B-B14F-4D97-AF65-F5344CB8AC3E}">
-        <p14:creationId xmlns:p14="http://schemas.microsoft.com/office/powerpoint/2010/main" val="2360600143"/>
+        <p14:creationId xmlns:p14="http://schemas.microsoft.com/office/powerpoint/2010/main" val="4056151214"/>
       </p:ext>
     </p:extLst>
   </p:cSld>
@@ -547,7 +547,7 @@
           <p:cNvPr id="2" name="세로 제목 1">
             <a:extLst>
               <a:ext uri="{FF2B5EF4-FFF2-40B4-BE49-F238E27FC236}">
-                <a16:creationId xmlns:a16="http://schemas.microsoft.com/office/drawing/2014/main" id="{BD948238-7B16-F32A-32D1-90033B4F3477}"/>
+                <a16:creationId xmlns:a16="http://schemas.microsoft.com/office/drawing/2014/main" id="{9E83CA69-FF01-AF99-6793-8D0B1F570397}"/>
               </a:ext>
             </a:extLst>
           </p:cNvPr>
@@ -580,7 +580,7 @@
           <p:cNvPr id="3" name="세로 텍스트 개체 틀 2">
             <a:extLst>
               <a:ext uri="{FF2B5EF4-FFF2-40B4-BE49-F238E27FC236}">
-                <a16:creationId xmlns:a16="http://schemas.microsoft.com/office/drawing/2014/main" id="{72E3D09B-9C5C-A842-0B39-5060D9BB9D2C}"/>
+                <a16:creationId xmlns:a16="http://schemas.microsoft.com/office/drawing/2014/main" id="{5295330D-711F-AEB1-33CA-24B2A0015F0C}"/>
               </a:ext>
             </a:extLst>
           </p:cNvPr>
@@ -642,7 +642,7 @@
           <p:cNvPr id="4" name="날짜 개체 틀 3">
             <a:extLst>
               <a:ext uri="{FF2B5EF4-FFF2-40B4-BE49-F238E27FC236}">
-                <a16:creationId xmlns:a16="http://schemas.microsoft.com/office/drawing/2014/main" id="{6709CBEC-CBB1-3ABB-847D-545D5398C28D}"/>
+                <a16:creationId xmlns:a16="http://schemas.microsoft.com/office/drawing/2014/main" id="{AFE2432A-8E60-EC80-73E7-C4A1D7A7BA37}"/>
               </a:ext>
             </a:extLst>
           </p:cNvPr>
@@ -658,9 +658,9 @@
           <a:bodyPr/>
           <a:lstStyle/>
           <a:p>
-            <a:fld id="{37A6BA30-5587-4442-AF77-A7B435B4C7C8}" type="datetimeFigureOut">
+            <a:fld id="{43E4A4A8-B4B0-45DC-B516-12D2C29E74C6}" type="datetimeFigureOut">
               <a:rPr lang="ko-KR" altLang="en-US" smtClean="0"/>
-              <a:t>2026-06-19</a:t>
+              <a:t>2026-06-20</a:t>
             </a:fld>
             <a:endParaRPr lang="ko-KR" altLang="en-US"/>
           </a:p>
@@ -671,7 +671,7 @@
           <p:cNvPr id="5" name="바닥글 개체 틀 4">
             <a:extLst>
               <a:ext uri="{FF2B5EF4-FFF2-40B4-BE49-F238E27FC236}">
-                <a16:creationId xmlns:a16="http://schemas.microsoft.com/office/drawing/2014/main" id="{20D4665C-0207-75A2-0883-3B395B15F32C}"/>
+                <a16:creationId xmlns:a16="http://schemas.microsoft.com/office/drawing/2014/main" id="{4FFB9448-D113-38A1-60EF-69BB685500B8}"/>
               </a:ext>
             </a:extLst>
           </p:cNvPr>
@@ -696,7 +696,7 @@
           <p:cNvPr id="6" name="슬라이드 번호 개체 틀 5">
             <a:extLst>
               <a:ext uri="{FF2B5EF4-FFF2-40B4-BE49-F238E27FC236}">
-                <a16:creationId xmlns:a16="http://schemas.microsoft.com/office/drawing/2014/main" id="{6B5FFA6C-E561-F45E-8EF4-445AA3ABD9E6}"/>
+                <a16:creationId xmlns:a16="http://schemas.microsoft.com/office/drawing/2014/main" id="{6B2D2B8C-4257-6446-4A02-3CF0047B3574}"/>
               </a:ext>
             </a:extLst>
           </p:cNvPr>
@@ -712,7 +712,7 @@
           <a:bodyPr/>
           <a:lstStyle/>
           <a:p>
-            <a:fld id="{D1DEAAE1-9523-4F91-9AA1-FE659F1DC52B}" type="slidenum">
+            <a:fld id="{DA293E9B-4C70-475B-B5B5-C6D1CDF11403}" type="slidenum">
               <a:rPr lang="ko-KR" altLang="en-US" smtClean="0"/>
               <a:t>‹#›</a:t>
             </a:fld>
@@ -723,7 +723,7 @@
     </p:spTree>
     <p:extLst>
       <p:ext uri="{BB962C8B-B14F-4D97-AF65-F5344CB8AC3E}">
-        <p14:creationId xmlns:p14="http://schemas.microsoft.com/office/powerpoint/2010/main" val="3997767716"/>
+        <p14:creationId xmlns:p14="http://schemas.microsoft.com/office/powerpoint/2010/main" val="944839595"/>
       </p:ext>
     </p:extLst>
   </p:cSld>
@@ -755,7 +755,7 @@
           <p:cNvPr id="2" name="제목 1">
             <a:extLst>
               <a:ext uri="{FF2B5EF4-FFF2-40B4-BE49-F238E27FC236}">
-                <a16:creationId xmlns:a16="http://schemas.microsoft.com/office/drawing/2014/main" id="{5A734291-DC03-9D00-C1B5-5FFBF18013E4}"/>
+                <a16:creationId xmlns:a16="http://schemas.microsoft.com/office/drawing/2014/main" id="{75E2402C-D230-B612-B365-535E96EBDE31}"/>
               </a:ext>
             </a:extLst>
           </p:cNvPr>
@@ -783,7 +783,7 @@
           <p:cNvPr id="3" name="내용 개체 틀 2">
             <a:extLst>
               <a:ext uri="{FF2B5EF4-FFF2-40B4-BE49-F238E27FC236}">
-                <a16:creationId xmlns:a16="http://schemas.microsoft.com/office/drawing/2014/main" id="{F10DF0FD-CDCA-F54B-B44B-619EEFE52DDD}"/>
+                <a16:creationId xmlns:a16="http://schemas.microsoft.com/office/drawing/2014/main" id="{84DB5EEB-9713-5D74-2A1B-A5BAFC214F16}"/>
               </a:ext>
             </a:extLst>
           </p:cNvPr>
@@ -840,7 +840,7 @@
           <p:cNvPr id="4" name="날짜 개체 틀 3">
             <a:extLst>
               <a:ext uri="{FF2B5EF4-FFF2-40B4-BE49-F238E27FC236}">
-                <a16:creationId xmlns:a16="http://schemas.microsoft.com/office/drawing/2014/main" id="{535893D4-0035-31F0-E84C-7C34A93DCB19}"/>
+                <a16:creationId xmlns:a16="http://schemas.microsoft.com/office/drawing/2014/main" id="{8C15A69A-1B82-FE1E-F7A1-840856F450DE}"/>
               </a:ext>
             </a:extLst>
           </p:cNvPr>
@@ -856,9 +856,9 @@
           <a:bodyPr/>
           <a:lstStyle/>
           <a:p>
-            <a:fld id="{37A6BA30-5587-4442-AF77-A7B435B4C7C8}" type="datetimeFigureOut">
+            <a:fld id="{43E4A4A8-B4B0-45DC-B516-12D2C29E74C6}" type="datetimeFigureOut">
               <a:rPr lang="ko-KR" altLang="en-US" smtClean="0"/>
-              <a:t>2026-06-19</a:t>
+              <a:t>2026-06-20</a:t>
             </a:fld>
             <a:endParaRPr lang="ko-KR" altLang="en-US"/>
           </a:p>
@@ -869,7 +869,7 @@
           <p:cNvPr id="5" name="바닥글 개체 틀 4">
             <a:extLst>
               <a:ext uri="{FF2B5EF4-FFF2-40B4-BE49-F238E27FC236}">
-                <a16:creationId xmlns:a16="http://schemas.microsoft.com/office/drawing/2014/main" id="{709223AE-DFC9-E5A5-4DB2-2C9951DC3380}"/>
+                <a16:creationId xmlns:a16="http://schemas.microsoft.com/office/drawing/2014/main" id="{4D2FD388-EB9B-F899-9678-37C72931B445}"/>
               </a:ext>
             </a:extLst>
           </p:cNvPr>
@@ -894,7 +894,7 @@
           <p:cNvPr id="6" name="슬라이드 번호 개체 틀 5">
             <a:extLst>
               <a:ext uri="{FF2B5EF4-FFF2-40B4-BE49-F238E27FC236}">
-                <a16:creationId xmlns:a16="http://schemas.microsoft.com/office/drawing/2014/main" id="{78A75397-7286-7095-BC2F-B38B311E3695}"/>
+                <a16:creationId xmlns:a16="http://schemas.microsoft.com/office/drawing/2014/main" id="{9D073713-D0FE-1682-9798-92D5BB14EFE8}"/>
               </a:ext>
             </a:extLst>
           </p:cNvPr>
@@ -910,7 +910,7 @@
           <a:bodyPr/>
           <a:lstStyle/>
           <a:p>
-            <a:fld id="{D1DEAAE1-9523-4F91-9AA1-FE659F1DC52B}" type="slidenum">
+            <a:fld id="{DA293E9B-4C70-475B-B5B5-C6D1CDF11403}" type="slidenum">
               <a:rPr lang="ko-KR" altLang="en-US" smtClean="0"/>
               <a:t>‹#›</a:t>
             </a:fld>
@@ -921,7 +921,7 @@
     </p:spTree>
     <p:extLst>
       <p:ext uri="{BB962C8B-B14F-4D97-AF65-F5344CB8AC3E}">
-        <p14:creationId xmlns:p14="http://schemas.microsoft.com/office/powerpoint/2010/main" val="1064622322"/>
+        <p14:creationId xmlns:p14="http://schemas.microsoft.com/office/powerpoint/2010/main" val="3522726834"/>
       </p:ext>
     </p:extLst>
   </p:cSld>
@@ -953,7 +953,7 @@
           <p:cNvPr id="2" name="제목 1">
             <a:extLst>
               <a:ext uri="{FF2B5EF4-FFF2-40B4-BE49-F238E27FC236}">
-                <a16:creationId xmlns:a16="http://schemas.microsoft.com/office/drawing/2014/main" id="{0C6CE29E-D438-D296-5C70-B57AD8D51893}"/>
+                <a16:creationId xmlns:a16="http://schemas.microsoft.com/office/drawing/2014/main" id="{16FDC8F6-7D20-68B0-2AA6-A097F50A1997}"/>
               </a:ext>
             </a:extLst>
           </p:cNvPr>
@@ -990,7 +990,7 @@
           <p:cNvPr id="3" name="텍스트 개체 틀 2">
             <a:extLst>
               <a:ext uri="{FF2B5EF4-FFF2-40B4-BE49-F238E27FC236}">
-                <a16:creationId xmlns:a16="http://schemas.microsoft.com/office/drawing/2014/main" id="{6E602F27-1075-14B5-0737-A85AD0CCC0AF}"/>
+                <a16:creationId xmlns:a16="http://schemas.microsoft.com/office/drawing/2014/main" id="{052206F3-26C3-1A91-4A45-CD1F16F7ACE5}"/>
               </a:ext>
             </a:extLst>
           </p:cNvPr>
@@ -1115,7 +1115,7 @@
           <p:cNvPr id="4" name="날짜 개체 틀 3">
             <a:extLst>
               <a:ext uri="{FF2B5EF4-FFF2-40B4-BE49-F238E27FC236}">
-                <a16:creationId xmlns:a16="http://schemas.microsoft.com/office/drawing/2014/main" id="{63163966-36C6-5DF1-DD9D-20E4D7168004}"/>
+                <a16:creationId xmlns:a16="http://schemas.microsoft.com/office/drawing/2014/main" id="{709FC770-B056-1AFC-AF64-0A1ACC7B0F9D}"/>
               </a:ext>
             </a:extLst>
           </p:cNvPr>
@@ -1131,9 +1131,9 @@
           <a:bodyPr/>
           <a:lstStyle/>
           <a:p>
-            <a:fld id="{37A6BA30-5587-4442-AF77-A7B435B4C7C8}" type="datetimeFigureOut">
+            <a:fld id="{43E4A4A8-B4B0-45DC-B516-12D2C29E74C6}" type="datetimeFigureOut">
               <a:rPr lang="ko-KR" altLang="en-US" smtClean="0"/>
-              <a:t>2026-06-19</a:t>
+              <a:t>2026-06-20</a:t>
             </a:fld>
             <a:endParaRPr lang="ko-KR" altLang="en-US"/>
           </a:p>
@@ -1144,7 +1144,7 @@
           <p:cNvPr id="5" name="바닥글 개체 틀 4">
             <a:extLst>
               <a:ext uri="{FF2B5EF4-FFF2-40B4-BE49-F238E27FC236}">
-                <a16:creationId xmlns:a16="http://schemas.microsoft.com/office/drawing/2014/main" id="{32BF48D4-F04D-CE7D-6868-55AB1670FB1B}"/>
+                <a16:creationId xmlns:a16="http://schemas.microsoft.com/office/drawing/2014/main" id="{5C43959F-93EA-F634-ADE7-EB33A9DC8A35}"/>
               </a:ext>
             </a:extLst>
           </p:cNvPr>
@@ -1169,7 +1169,7 @@
           <p:cNvPr id="6" name="슬라이드 번호 개체 틀 5">
             <a:extLst>
               <a:ext uri="{FF2B5EF4-FFF2-40B4-BE49-F238E27FC236}">
-                <a16:creationId xmlns:a16="http://schemas.microsoft.com/office/drawing/2014/main" id="{EB96B1E6-6892-0A28-59C3-499383CCE5F1}"/>
+                <a16:creationId xmlns:a16="http://schemas.microsoft.com/office/drawing/2014/main" id="{39164BDD-352A-DD73-7ABE-680EFE764DC7}"/>
               </a:ext>
             </a:extLst>
           </p:cNvPr>
@@ -1185,7 +1185,7 @@
           <a:bodyPr/>
           <a:lstStyle/>
           <a:p>
-            <a:fld id="{D1DEAAE1-9523-4F91-9AA1-FE659F1DC52B}" type="slidenum">
+            <a:fld id="{DA293E9B-4C70-475B-B5B5-C6D1CDF11403}" type="slidenum">
               <a:rPr lang="ko-KR" altLang="en-US" smtClean="0"/>
               <a:t>‹#›</a:t>
             </a:fld>
@@ -1196,7 +1196,7 @@
     </p:spTree>
     <p:extLst>
       <p:ext uri="{BB962C8B-B14F-4D97-AF65-F5344CB8AC3E}">
-        <p14:creationId xmlns:p14="http://schemas.microsoft.com/office/powerpoint/2010/main" val="149861998"/>
+        <p14:creationId xmlns:p14="http://schemas.microsoft.com/office/powerpoint/2010/main" val="1495531082"/>
       </p:ext>
     </p:extLst>
   </p:cSld>
@@ -1228,7 +1228,7 @@
           <p:cNvPr id="2" name="제목 1">
             <a:extLst>
               <a:ext uri="{FF2B5EF4-FFF2-40B4-BE49-F238E27FC236}">
-                <a16:creationId xmlns:a16="http://schemas.microsoft.com/office/drawing/2014/main" id="{C19C8B7D-2272-E424-0F69-E49599D6FCAB}"/>
+                <a16:creationId xmlns:a16="http://schemas.microsoft.com/office/drawing/2014/main" id="{240BDDD3-D2F5-1171-836F-0B23BFBE39BB}"/>
               </a:ext>
             </a:extLst>
           </p:cNvPr>
@@ -1256,7 +1256,7 @@
           <p:cNvPr id="3" name="내용 개체 틀 2">
             <a:extLst>
               <a:ext uri="{FF2B5EF4-FFF2-40B4-BE49-F238E27FC236}">
-                <a16:creationId xmlns:a16="http://schemas.microsoft.com/office/drawing/2014/main" id="{97AC6775-0B77-95DA-5035-D12B89CDB2B4}"/>
+                <a16:creationId xmlns:a16="http://schemas.microsoft.com/office/drawing/2014/main" id="{9DB1A758-1346-B628-D163-92625B34A2D2}"/>
               </a:ext>
             </a:extLst>
           </p:cNvPr>
@@ -1318,7 +1318,7 @@
           <p:cNvPr id="4" name="내용 개체 틀 3">
             <a:extLst>
               <a:ext uri="{FF2B5EF4-FFF2-40B4-BE49-F238E27FC236}">
-                <a16:creationId xmlns:a16="http://schemas.microsoft.com/office/drawing/2014/main" id="{E2F50498-65B2-A555-2D7E-B1FE90C16D46}"/>
+                <a16:creationId xmlns:a16="http://schemas.microsoft.com/office/drawing/2014/main" id="{6BA0F76D-4958-1BCE-3978-B95D3B8C3AED}"/>
               </a:ext>
             </a:extLst>
           </p:cNvPr>
@@ -1380,7 +1380,7 @@
           <p:cNvPr id="5" name="날짜 개체 틀 4">
             <a:extLst>
               <a:ext uri="{FF2B5EF4-FFF2-40B4-BE49-F238E27FC236}">
-                <a16:creationId xmlns:a16="http://schemas.microsoft.com/office/drawing/2014/main" id="{F4F61115-0871-C7BA-570F-3ED89E98D7D0}"/>
+                <a16:creationId xmlns:a16="http://schemas.microsoft.com/office/drawing/2014/main" id="{84847E04-8C9D-5ECD-7151-F7EAD4953CA8}"/>
               </a:ext>
             </a:extLst>
           </p:cNvPr>
@@ -1396,9 +1396,9 @@
           <a:bodyPr/>
           <a:lstStyle/>
           <a:p>
-            <a:fld id="{37A6BA30-5587-4442-AF77-A7B435B4C7C8}" type="datetimeFigureOut">
+            <a:fld id="{43E4A4A8-B4B0-45DC-B516-12D2C29E74C6}" type="datetimeFigureOut">
               <a:rPr lang="ko-KR" altLang="en-US" smtClean="0"/>
-              <a:t>2026-06-19</a:t>
+              <a:t>2026-06-20</a:t>
             </a:fld>
             <a:endParaRPr lang="ko-KR" altLang="en-US"/>
           </a:p>
@@ -1409,7 +1409,7 @@
           <p:cNvPr id="6" name="바닥글 개체 틀 5">
             <a:extLst>
               <a:ext uri="{FF2B5EF4-FFF2-40B4-BE49-F238E27FC236}">
-                <a16:creationId xmlns:a16="http://schemas.microsoft.com/office/drawing/2014/main" id="{78147BA8-6E50-1009-A7E7-E1C2A044E747}"/>
+                <a16:creationId xmlns:a16="http://schemas.microsoft.com/office/drawing/2014/main" id="{63236F74-E92D-545D-F540-27E77F0E48D0}"/>
               </a:ext>
             </a:extLst>
           </p:cNvPr>
@@ -1434,7 +1434,7 @@
           <p:cNvPr id="7" name="슬라이드 번호 개체 틀 6">
             <a:extLst>
               <a:ext uri="{FF2B5EF4-FFF2-40B4-BE49-F238E27FC236}">
-                <a16:creationId xmlns:a16="http://schemas.microsoft.com/office/drawing/2014/main" id="{A8213329-9F92-E681-5F18-447D8334581F}"/>
+                <a16:creationId xmlns:a16="http://schemas.microsoft.com/office/drawing/2014/main" id="{2DA2F67F-65AD-387E-95E0-3F37FCCA486B}"/>
               </a:ext>
             </a:extLst>
           </p:cNvPr>
@@ -1450,7 +1450,7 @@
           <a:bodyPr/>
           <a:lstStyle/>
           <a:p>
-            <a:fld id="{D1DEAAE1-9523-4F91-9AA1-FE659F1DC52B}" type="slidenum">
+            <a:fld id="{DA293E9B-4C70-475B-B5B5-C6D1CDF11403}" type="slidenum">
               <a:rPr lang="ko-KR" altLang="en-US" smtClean="0"/>
               <a:t>‹#›</a:t>
             </a:fld>
@@ -1461,7 +1461,7 @@
     </p:spTree>
     <p:extLst>
       <p:ext uri="{BB962C8B-B14F-4D97-AF65-F5344CB8AC3E}">
-        <p14:creationId xmlns:p14="http://schemas.microsoft.com/office/powerpoint/2010/main" val="3107413877"/>
+        <p14:creationId xmlns:p14="http://schemas.microsoft.com/office/powerpoint/2010/main" val="976260584"/>
       </p:ext>
     </p:extLst>
   </p:cSld>
@@ -1493,7 +1493,7 @@
           <p:cNvPr id="2" name="제목 1">
             <a:extLst>
               <a:ext uri="{FF2B5EF4-FFF2-40B4-BE49-F238E27FC236}">
-                <a16:creationId xmlns:a16="http://schemas.microsoft.com/office/drawing/2014/main" id="{2CE4859B-8E88-90FE-8836-F6164E407D39}"/>
+                <a16:creationId xmlns:a16="http://schemas.microsoft.com/office/drawing/2014/main" id="{299F57F4-1AB0-A07F-38A7-C9A6ACB1063B}"/>
               </a:ext>
             </a:extLst>
           </p:cNvPr>
@@ -1526,7 +1526,7 @@
           <p:cNvPr id="3" name="텍스트 개체 틀 2">
             <a:extLst>
               <a:ext uri="{FF2B5EF4-FFF2-40B4-BE49-F238E27FC236}">
-                <a16:creationId xmlns:a16="http://schemas.microsoft.com/office/drawing/2014/main" id="{EC368597-746F-F472-57B5-7C264905F6E6}"/>
+                <a16:creationId xmlns:a16="http://schemas.microsoft.com/office/drawing/2014/main" id="{391009DD-4E31-FEA6-042A-8B7E98438348}"/>
               </a:ext>
             </a:extLst>
           </p:cNvPr>
@@ -1597,7 +1597,7 @@
           <p:cNvPr id="4" name="내용 개체 틀 3">
             <a:extLst>
               <a:ext uri="{FF2B5EF4-FFF2-40B4-BE49-F238E27FC236}">
-                <a16:creationId xmlns:a16="http://schemas.microsoft.com/office/drawing/2014/main" id="{79ADA2B1-20D9-89E4-DC00-62766F52E6F6}"/>
+                <a16:creationId xmlns:a16="http://schemas.microsoft.com/office/drawing/2014/main" id="{340C2438-C21C-C90E-F10D-F1B471F651A1}"/>
               </a:ext>
             </a:extLst>
           </p:cNvPr>
@@ -1659,7 +1659,7 @@
           <p:cNvPr id="5" name="텍스트 개체 틀 4">
             <a:extLst>
               <a:ext uri="{FF2B5EF4-FFF2-40B4-BE49-F238E27FC236}">
-                <a16:creationId xmlns:a16="http://schemas.microsoft.com/office/drawing/2014/main" id="{005CB960-A95D-4216-8005-B3F0DE469012}"/>
+                <a16:creationId xmlns:a16="http://schemas.microsoft.com/office/drawing/2014/main" id="{AC90015F-9112-38A7-AC04-59D73A320726}"/>
               </a:ext>
             </a:extLst>
           </p:cNvPr>
@@ -1730,7 +1730,7 @@
           <p:cNvPr id="6" name="내용 개체 틀 5">
             <a:extLst>
               <a:ext uri="{FF2B5EF4-FFF2-40B4-BE49-F238E27FC236}">
-                <a16:creationId xmlns:a16="http://schemas.microsoft.com/office/drawing/2014/main" id="{930391A2-2901-883E-192D-4920CE3986BB}"/>
+                <a16:creationId xmlns:a16="http://schemas.microsoft.com/office/drawing/2014/main" id="{0987EC59-FF83-ECC8-B4A0-08C0D3077268}"/>
               </a:ext>
             </a:extLst>
           </p:cNvPr>
@@ -1792,7 +1792,7 @@
           <p:cNvPr id="7" name="날짜 개체 틀 6">
             <a:extLst>
               <a:ext uri="{FF2B5EF4-FFF2-40B4-BE49-F238E27FC236}">
-                <a16:creationId xmlns:a16="http://schemas.microsoft.com/office/drawing/2014/main" id="{F497CE13-D2D2-E71B-7C12-5D3E37CC026C}"/>
+                <a16:creationId xmlns:a16="http://schemas.microsoft.com/office/drawing/2014/main" id="{281578B1-7FBD-A367-7D4C-5424326D6C5A}"/>
               </a:ext>
             </a:extLst>
           </p:cNvPr>
@@ -1808,9 +1808,9 @@
           <a:bodyPr/>
           <a:lstStyle/>
           <a:p>
-            <a:fld id="{37A6BA30-5587-4442-AF77-A7B435B4C7C8}" type="datetimeFigureOut">
+            <a:fld id="{43E4A4A8-B4B0-45DC-B516-12D2C29E74C6}" type="datetimeFigureOut">
               <a:rPr lang="ko-KR" altLang="en-US" smtClean="0"/>
-              <a:t>2026-06-19</a:t>
+              <a:t>2026-06-20</a:t>
             </a:fld>
             <a:endParaRPr lang="ko-KR" altLang="en-US"/>
           </a:p>
@@ -1821,7 +1821,7 @@
           <p:cNvPr id="8" name="바닥글 개체 틀 7">
             <a:extLst>
               <a:ext uri="{FF2B5EF4-FFF2-40B4-BE49-F238E27FC236}">
-                <a16:creationId xmlns:a16="http://schemas.microsoft.com/office/drawing/2014/main" id="{FDA3A9C4-C3DC-C350-6D36-B98EE964B37C}"/>
+                <a16:creationId xmlns:a16="http://schemas.microsoft.com/office/drawing/2014/main" id="{8B03B8AB-DC1F-E8A0-CBDF-EAD9398E521B}"/>
               </a:ext>
             </a:extLst>
           </p:cNvPr>
@@ -1846,7 +1846,7 @@
           <p:cNvPr id="9" name="슬라이드 번호 개체 틀 8">
             <a:extLst>
               <a:ext uri="{FF2B5EF4-FFF2-40B4-BE49-F238E27FC236}">
-                <a16:creationId xmlns:a16="http://schemas.microsoft.com/office/drawing/2014/main" id="{C2559D87-3B90-D9D5-0D0E-514FCD824A4B}"/>
+                <a16:creationId xmlns:a16="http://schemas.microsoft.com/office/drawing/2014/main" id="{925CB8AB-9877-38CE-6C72-71D4D9E29540}"/>
               </a:ext>
             </a:extLst>
           </p:cNvPr>
@@ -1862,7 +1862,7 @@
           <a:bodyPr/>
           <a:lstStyle/>
           <a:p>
-            <a:fld id="{D1DEAAE1-9523-4F91-9AA1-FE659F1DC52B}" type="slidenum">
+            <a:fld id="{DA293E9B-4C70-475B-B5B5-C6D1CDF11403}" type="slidenum">
               <a:rPr lang="ko-KR" altLang="en-US" smtClean="0"/>
               <a:t>‹#›</a:t>
             </a:fld>
@@ -1873,7 +1873,7 @@
     </p:spTree>
     <p:extLst>
       <p:ext uri="{BB962C8B-B14F-4D97-AF65-F5344CB8AC3E}">
-        <p14:creationId xmlns:p14="http://schemas.microsoft.com/office/powerpoint/2010/main" val="2129526242"/>
+        <p14:creationId xmlns:p14="http://schemas.microsoft.com/office/powerpoint/2010/main" val="2484358139"/>
       </p:ext>
     </p:extLst>
   </p:cSld>
@@ -1905,7 +1905,7 @@
           <p:cNvPr id="2" name="제목 1">
             <a:extLst>
               <a:ext uri="{FF2B5EF4-FFF2-40B4-BE49-F238E27FC236}">
-                <a16:creationId xmlns:a16="http://schemas.microsoft.com/office/drawing/2014/main" id="{980C8D56-8746-A960-692A-FE92470A9E3E}"/>
+                <a16:creationId xmlns:a16="http://schemas.microsoft.com/office/drawing/2014/main" id="{07B0180F-AC70-973F-A8A1-0166A3897E08}"/>
               </a:ext>
             </a:extLst>
           </p:cNvPr>
@@ -1933,7 +1933,7 @@
           <p:cNvPr id="3" name="날짜 개체 틀 2">
             <a:extLst>
               <a:ext uri="{FF2B5EF4-FFF2-40B4-BE49-F238E27FC236}">
-                <a16:creationId xmlns:a16="http://schemas.microsoft.com/office/drawing/2014/main" id="{46AA68BF-442C-825C-2033-E79DAB8670DC}"/>
+                <a16:creationId xmlns:a16="http://schemas.microsoft.com/office/drawing/2014/main" id="{14E16062-BCA5-C798-80C7-26C92DC5A257}"/>
               </a:ext>
             </a:extLst>
           </p:cNvPr>
@@ -1949,9 +1949,9 @@
           <a:bodyPr/>
           <a:lstStyle/>
           <a:p>
-            <a:fld id="{37A6BA30-5587-4442-AF77-A7B435B4C7C8}" type="datetimeFigureOut">
+            <a:fld id="{43E4A4A8-B4B0-45DC-B516-12D2C29E74C6}" type="datetimeFigureOut">
               <a:rPr lang="ko-KR" altLang="en-US" smtClean="0"/>
-              <a:t>2026-06-19</a:t>
+              <a:t>2026-06-20</a:t>
             </a:fld>
             <a:endParaRPr lang="ko-KR" altLang="en-US"/>
           </a:p>
@@ -1962,7 +1962,7 @@
           <p:cNvPr id="4" name="바닥글 개체 틀 3">
             <a:extLst>
               <a:ext uri="{FF2B5EF4-FFF2-40B4-BE49-F238E27FC236}">
-                <a16:creationId xmlns:a16="http://schemas.microsoft.com/office/drawing/2014/main" id="{A81A38BE-80A9-A3F7-DE7A-26621E560779}"/>
+                <a16:creationId xmlns:a16="http://schemas.microsoft.com/office/drawing/2014/main" id="{5FBAC69D-0863-7E03-1C1E-111B1344AAEE}"/>
               </a:ext>
             </a:extLst>
           </p:cNvPr>
@@ -1987,7 +1987,7 @@
           <p:cNvPr id="5" name="슬라이드 번호 개체 틀 4">
             <a:extLst>
               <a:ext uri="{FF2B5EF4-FFF2-40B4-BE49-F238E27FC236}">
-                <a16:creationId xmlns:a16="http://schemas.microsoft.com/office/drawing/2014/main" id="{A3A7352E-C9EC-0905-778B-E271C5E083F8}"/>
+                <a16:creationId xmlns:a16="http://schemas.microsoft.com/office/drawing/2014/main" id="{A53F28BB-A5B9-3D76-9E89-AD362F81FAAC}"/>
               </a:ext>
             </a:extLst>
           </p:cNvPr>
@@ -2003,7 +2003,7 @@
           <a:bodyPr/>
           <a:lstStyle/>
           <a:p>
-            <a:fld id="{D1DEAAE1-9523-4F91-9AA1-FE659F1DC52B}" type="slidenum">
+            <a:fld id="{DA293E9B-4C70-475B-B5B5-C6D1CDF11403}" type="slidenum">
               <a:rPr lang="ko-KR" altLang="en-US" smtClean="0"/>
               <a:t>‹#›</a:t>
             </a:fld>
@@ -2014,7 +2014,7 @@
     </p:spTree>
     <p:extLst>
       <p:ext uri="{BB962C8B-B14F-4D97-AF65-F5344CB8AC3E}">
-        <p14:creationId xmlns:p14="http://schemas.microsoft.com/office/powerpoint/2010/main" val="186640407"/>
+        <p14:creationId xmlns:p14="http://schemas.microsoft.com/office/powerpoint/2010/main" val="46434286"/>
       </p:ext>
     </p:extLst>
   </p:cSld>
@@ -2046,7 +2046,7 @@
           <p:cNvPr id="2" name="날짜 개체 틀 1">
             <a:extLst>
               <a:ext uri="{FF2B5EF4-FFF2-40B4-BE49-F238E27FC236}">
-                <a16:creationId xmlns:a16="http://schemas.microsoft.com/office/drawing/2014/main" id="{9635F1FA-2075-FB6D-268D-A8A5097B12D8}"/>
+                <a16:creationId xmlns:a16="http://schemas.microsoft.com/office/drawing/2014/main" id="{B09BE9A0-6DB3-7516-D6EE-F7EC6A250891}"/>
               </a:ext>
             </a:extLst>
           </p:cNvPr>
@@ -2062,9 +2062,9 @@
           <a:bodyPr/>
           <a:lstStyle/>
           <a:p>
-            <a:fld id="{37A6BA30-5587-4442-AF77-A7B435B4C7C8}" type="datetimeFigureOut">
+            <a:fld id="{43E4A4A8-B4B0-45DC-B516-12D2C29E74C6}" type="datetimeFigureOut">
               <a:rPr lang="ko-KR" altLang="en-US" smtClean="0"/>
-              <a:t>2026-06-19</a:t>
+              <a:t>2026-06-20</a:t>
             </a:fld>
             <a:endParaRPr lang="ko-KR" altLang="en-US"/>
           </a:p>
@@ -2075,7 +2075,7 @@
           <p:cNvPr id="3" name="바닥글 개체 틀 2">
             <a:extLst>
               <a:ext uri="{FF2B5EF4-FFF2-40B4-BE49-F238E27FC236}">
-                <a16:creationId xmlns:a16="http://schemas.microsoft.com/office/drawing/2014/main" id="{A67EC4A0-BD51-3BDC-2959-1AF7B585B110}"/>
+                <a16:creationId xmlns:a16="http://schemas.microsoft.com/office/drawing/2014/main" id="{6171E29A-7072-AAD9-775D-EC95523BE33B}"/>
               </a:ext>
             </a:extLst>
           </p:cNvPr>
@@ -2100,7 +2100,7 @@
           <p:cNvPr id="4" name="슬라이드 번호 개체 틀 3">
             <a:extLst>
               <a:ext uri="{FF2B5EF4-FFF2-40B4-BE49-F238E27FC236}">
-                <a16:creationId xmlns:a16="http://schemas.microsoft.com/office/drawing/2014/main" id="{91EAA5F1-8B02-D1FB-5FDC-196755027E84}"/>
+                <a16:creationId xmlns:a16="http://schemas.microsoft.com/office/drawing/2014/main" id="{6A646E0B-65D0-B014-95B5-5C5FC35FE260}"/>
               </a:ext>
             </a:extLst>
           </p:cNvPr>
@@ -2116,7 +2116,7 @@
           <a:bodyPr/>
           <a:lstStyle/>
           <a:p>
-            <a:fld id="{D1DEAAE1-9523-4F91-9AA1-FE659F1DC52B}" type="slidenum">
+            <a:fld id="{DA293E9B-4C70-475B-B5B5-C6D1CDF11403}" type="slidenum">
               <a:rPr lang="ko-KR" altLang="en-US" smtClean="0"/>
               <a:t>‹#›</a:t>
             </a:fld>
@@ -2127,7 +2127,7 @@
     </p:spTree>
     <p:extLst>
       <p:ext uri="{BB962C8B-B14F-4D97-AF65-F5344CB8AC3E}">
-        <p14:creationId xmlns:p14="http://schemas.microsoft.com/office/powerpoint/2010/main" val="1651307502"/>
+        <p14:creationId xmlns:p14="http://schemas.microsoft.com/office/powerpoint/2010/main" val="4216673167"/>
       </p:ext>
     </p:extLst>
   </p:cSld>
@@ -2159,7 +2159,7 @@
           <p:cNvPr id="2" name="제목 1">
             <a:extLst>
               <a:ext uri="{FF2B5EF4-FFF2-40B4-BE49-F238E27FC236}">
-                <a16:creationId xmlns:a16="http://schemas.microsoft.com/office/drawing/2014/main" id="{81DF3020-173B-7C4A-F1D0-4901C3F15F12}"/>
+                <a16:creationId xmlns:a16="http://schemas.microsoft.com/office/drawing/2014/main" id="{BF085981-1BD0-E410-3971-4EF1386A3336}"/>
               </a:ext>
             </a:extLst>
           </p:cNvPr>
@@ -2196,7 +2196,7 @@
           <p:cNvPr id="3" name="내용 개체 틀 2">
             <a:extLst>
               <a:ext uri="{FF2B5EF4-FFF2-40B4-BE49-F238E27FC236}">
-                <a16:creationId xmlns:a16="http://schemas.microsoft.com/office/drawing/2014/main" id="{D057BEB0-56DB-B531-D251-02FA9264EC81}"/>
+                <a16:creationId xmlns:a16="http://schemas.microsoft.com/office/drawing/2014/main" id="{14A2564F-D3B5-959F-9E26-D869B800E574}"/>
               </a:ext>
             </a:extLst>
           </p:cNvPr>
@@ -2286,7 +2286,7 @@
           <p:cNvPr id="4" name="텍스트 개체 틀 3">
             <a:extLst>
               <a:ext uri="{FF2B5EF4-FFF2-40B4-BE49-F238E27FC236}">
-                <a16:creationId xmlns:a16="http://schemas.microsoft.com/office/drawing/2014/main" id="{7D66F40D-7176-67A5-1F5A-21FC5C54F5F2}"/>
+                <a16:creationId xmlns:a16="http://schemas.microsoft.com/office/drawing/2014/main" id="{1C614818-D98B-84D2-6F93-3B83E2F5E9CE}"/>
               </a:ext>
             </a:extLst>
           </p:cNvPr>
@@ -2357,7 +2357,7 @@
           <p:cNvPr id="5" name="날짜 개체 틀 4">
             <a:extLst>
               <a:ext uri="{FF2B5EF4-FFF2-40B4-BE49-F238E27FC236}">
-                <a16:creationId xmlns:a16="http://schemas.microsoft.com/office/drawing/2014/main" id="{858EB0C4-DA5B-9CD7-804C-B92ABEE768A2}"/>
+                <a16:creationId xmlns:a16="http://schemas.microsoft.com/office/drawing/2014/main" id="{C1A698E3-0A70-A7E1-DEA3-8192DB4B481B}"/>
               </a:ext>
             </a:extLst>
           </p:cNvPr>
@@ -2373,9 +2373,9 @@
           <a:bodyPr/>
           <a:lstStyle/>
           <a:p>
-            <a:fld id="{37A6BA30-5587-4442-AF77-A7B435B4C7C8}" type="datetimeFigureOut">
+            <a:fld id="{43E4A4A8-B4B0-45DC-B516-12D2C29E74C6}" type="datetimeFigureOut">
               <a:rPr lang="ko-KR" altLang="en-US" smtClean="0"/>
-              <a:t>2026-06-19</a:t>
+              <a:t>2026-06-20</a:t>
             </a:fld>
             <a:endParaRPr lang="ko-KR" altLang="en-US"/>
           </a:p>
@@ -2386,7 +2386,7 @@
           <p:cNvPr id="6" name="바닥글 개체 틀 5">
             <a:extLst>
               <a:ext uri="{FF2B5EF4-FFF2-40B4-BE49-F238E27FC236}">
-                <a16:creationId xmlns:a16="http://schemas.microsoft.com/office/drawing/2014/main" id="{28978C9C-D6C9-4E0A-D421-86276812EF00}"/>
+                <a16:creationId xmlns:a16="http://schemas.microsoft.com/office/drawing/2014/main" id="{C77C85AF-E453-688A-ED8D-BA9A1DC65BAC}"/>
               </a:ext>
             </a:extLst>
           </p:cNvPr>
@@ -2411,7 +2411,7 @@
           <p:cNvPr id="7" name="슬라이드 번호 개체 틀 6">
             <a:extLst>
               <a:ext uri="{FF2B5EF4-FFF2-40B4-BE49-F238E27FC236}">
-                <a16:creationId xmlns:a16="http://schemas.microsoft.com/office/drawing/2014/main" id="{D4435DF5-B289-33FE-8848-C659AB4C2C8C}"/>
+                <a16:creationId xmlns:a16="http://schemas.microsoft.com/office/drawing/2014/main" id="{52720364-52AD-E5F8-FBC7-10870CBA2964}"/>
               </a:ext>
             </a:extLst>
           </p:cNvPr>
@@ -2427,7 +2427,7 @@
           <a:bodyPr/>
           <a:lstStyle/>
           <a:p>
-            <a:fld id="{D1DEAAE1-9523-4F91-9AA1-FE659F1DC52B}" type="slidenum">
+            <a:fld id="{DA293E9B-4C70-475B-B5B5-C6D1CDF11403}" type="slidenum">
               <a:rPr lang="ko-KR" altLang="en-US" smtClean="0"/>
               <a:t>‹#›</a:t>
             </a:fld>
@@ -2438,7 +2438,7 @@
     </p:spTree>
     <p:extLst>
       <p:ext uri="{BB962C8B-B14F-4D97-AF65-F5344CB8AC3E}">
-        <p14:creationId xmlns:p14="http://schemas.microsoft.com/office/powerpoint/2010/main" val="330747519"/>
+        <p14:creationId xmlns:p14="http://schemas.microsoft.com/office/powerpoint/2010/main" val="2657476335"/>
       </p:ext>
     </p:extLst>
   </p:cSld>
@@ -2470,7 +2470,7 @@
           <p:cNvPr id="2" name="제목 1">
             <a:extLst>
               <a:ext uri="{FF2B5EF4-FFF2-40B4-BE49-F238E27FC236}">
-                <a16:creationId xmlns:a16="http://schemas.microsoft.com/office/drawing/2014/main" id="{AF4FDF3C-D5AB-D978-E17A-28CD2C41B009}"/>
+                <a16:creationId xmlns:a16="http://schemas.microsoft.com/office/drawing/2014/main" id="{9FAC76D3-38EF-62E4-9AE3-F484B7E262C5}"/>
               </a:ext>
             </a:extLst>
           </p:cNvPr>
@@ -2507,7 +2507,7 @@
           <p:cNvPr id="3" name="그림 개체 틀 2">
             <a:extLst>
               <a:ext uri="{FF2B5EF4-FFF2-40B4-BE49-F238E27FC236}">
-                <a16:creationId xmlns:a16="http://schemas.microsoft.com/office/drawing/2014/main" id="{368C3EB7-F7FE-D849-BF43-172FDC04310A}"/>
+                <a16:creationId xmlns:a16="http://schemas.microsoft.com/office/drawing/2014/main" id="{74F5EE8B-2126-F985-644C-8409DDEEE9FD}"/>
               </a:ext>
             </a:extLst>
           </p:cNvPr>
@@ -2574,7 +2574,7 @@
           <p:cNvPr id="4" name="텍스트 개체 틀 3">
             <a:extLst>
               <a:ext uri="{FF2B5EF4-FFF2-40B4-BE49-F238E27FC236}">
-                <a16:creationId xmlns:a16="http://schemas.microsoft.com/office/drawing/2014/main" id="{B1FAE160-2765-7AB6-B51F-8EFBBDEED85A}"/>
+                <a16:creationId xmlns:a16="http://schemas.microsoft.com/office/drawing/2014/main" id="{3483E5D8-5C30-CFEB-3638-0459D0EC18CE}"/>
               </a:ext>
             </a:extLst>
           </p:cNvPr>
@@ -2645,7 +2645,7 @@
           <p:cNvPr id="5" name="날짜 개체 틀 4">
             <a:extLst>
               <a:ext uri="{FF2B5EF4-FFF2-40B4-BE49-F238E27FC236}">
-                <a16:creationId xmlns:a16="http://schemas.microsoft.com/office/drawing/2014/main" id="{217D1A3C-351C-A1DC-4AE4-C08F2103A3A5}"/>
+                <a16:creationId xmlns:a16="http://schemas.microsoft.com/office/drawing/2014/main" id="{1B3E7CDD-F1BB-85FC-95EB-AF84238C52E8}"/>
               </a:ext>
             </a:extLst>
           </p:cNvPr>
@@ -2661,9 +2661,9 @@
           <a:bodyPr/>
           <a:lstStyle/>
           <a:p>
-            <a:fld id="{37A6BA30-5587-4442-AF77-A7B435B4C7C8}" type="datetimeFigureOut">
+            <a:fld id="{43E4A4A8-B4B0-45DC-B516-12D2C29E74C6}" type="datetimeFigureOut">
               <a:rPr lang="ko-KR" altLang="en-US" smtClean="0"/>
-              <a:t>2026-06-19</a:t>
+              <a:t>2026-06-20</a:t>
             </a:fld>
             <a:endParaRPr lang="ko-KR" altLang="en-US"/>
           </a:p>
@@ -2674,7 +2674,7 @@
           <p:cNvPr id="6" name="바닥글 개체 틀 5">
             <a:extLst>
               <a:ext uri="{FF2B5EF4-FFF2-40B4-BE49-F238E27FC236}">
-                <a16:creationId xmlns:a16="http://schemas.microsoft.com/office/drawing/2014/main" id="{BC97E207-5D4A-1A2E-9364-6D0D82CC8DA4}"/>
+                <a16:creationId xmlns:a16="http://schemas.microsoft.com/office/drawing/2014/main" id="{DA98E4C2-9766-1139-42A0-B4A0B084E8F9}"/>
               </a:ext>
             </a:extLst>
           </p:cNvPr>
@@ -2699,7 +2699,7 @@
           <p:cNvPr id="7" name="슬라이드 번호 개체 틀 6">
             <a:extLst>
               <a:ext uri="{FF2B5EF4-FFF2-40B4-BE49-F238E27FC236}">
-                <a16:creationId xmlns:a16="http://schemas.microsoft.com/office/drawing/2014/main" id="{100A9759-5D75-1EBF-01DC-9EC54FA6E530}"/>
+                <a16:creationId xmlns:a16="http://schemas.microsoft.com/office/drawing/2014/main" id="{EF4B6C76-A677-CAB7-9293-189FCBC25A42}"/>
               </a:ext>
             </a:extLst>
           </p:cNvPr>
@@ -2715,7 +2715,7 @@
           <a:bodyPr/>
           <a:lstStyle/>
           <a:p>
-            <a:fld id="{D1DEAAE1-9523-4F91-9AA1-FE659F1DC52B}" type="slidenum">
+            <a:fld id="{DA293E9B-4C70-475B-B5B5-C6D1CDF11403}" type="slidenum">
               <a:rPr lang="ko-KR" altLang="en-US" smtClean="0"/>
               <a:t>‹#›</a:t>
             </a:fld>
@@ -2726,7 +2726,7 @@
     </p:spTree>
     <p:extLst>
       <p:ext uri="{BB962C8B-B14F-4D97-AF65-F5344CB8AC3E}">
-        <p14:creationId xmlns:p14="http://schemas.microsoft.com/office/powerpoint/2010/main" val="1120943280"/>
+        <p14:creationId xmlns:p14="http://schemas.microsoft.com/office/powerpoint/2010/main" val="2590053105"/>
       </p:ext>
     </p:extLst>
   </p:cSld>
@@ -2763,7 +2763,7 @@
           <p:cNvPr id="2" name="제목 개체 틀 1">
             <a:extLst>
               <a:ext uri="{FF2B5EF4-FFF2-40B4-BE49-F238E27FC236}">
-                <a16:creationId xmlns:a16="http://schemas.microsoft.com/office/drawing/2014/main" id="{9EB43992-E9C2-672A-B227-8696D5234AD2}"/>
+                <a16:creationId xmlns:a16="http://schemas.microsoft.com/office/drawing/2014/main" id="{51851B9C-98EB-9D24-317F-8E358421F825}"/>
               </a:ext>
             </a:extLst>
           </p:cNvPr>
@@ -2801,7 +2801,7 @@
           <p:cNvPr id="3" name="텍스트 개체 틀 2">
             <a:extLst>
               <a:ext uri="{FF2B5EF4-FFF2-40B4-BE49-F238E27FC236}">
-                <a16:creationId xmlns:a16="http://schemas.microsoft.com/office/drawing/2014/main" id="{B0B24729-3D38-D9B8-8501-5A807B999D0A}"/>
+                <a16:creationId xmlns:a16="http://schemas.microsoft.com/office/drawing/2014/main" id="{7BF5CA45-7E29-8D92-6E3B-E2162D48E7CC}"/>
               </a:ext>
             </a:extLst>
           </p:cNvPr>
@@ -2868,7 +2868,7 @@
           <p:cNvPr id="4" name="날짜 개체 틀 3">
             <a:extLst>
               <a:ext uri="{FF2B5EF4-FFF2-40B4-BE49-F238E27FC236}">
-                <a16:creationId xmlns:a16="http://schemas.microsoft.com/office/drawing/2014/main" id="{0A6BD229-831E-3ECA-6158-F95BCE3514CC}"/>
+                <a16:creationId xmlns:a16="http://schemas.microsoft.com/office/drawing/2014/main" id="{5FEF5DD0-4158-538B-DC6C-B2FB974DA1A8}"/>
               </a:ext>
             </a:extLst>
           </p:cNvPr>
@@ -2902,9 +2902,9 @@
             </a:lvl1pPr>
           </a:lstStyle>
           <a:p>
-            <a:fld id="{37A6BA30-5587-4442-AF77-A7B435B4C7C8}" type="datetimeFigureOut">
+            <a:fld id="{43E4A4A8-B4B0-45DC-B516-12D2C29E74C6}" type="datetimeFigureOut">
               <a:rPr lang="ko-KR" altLang="en-US" smtClean="0"/>
-              <a:t>2026-06-19</a:t>
+              <a:t>2026-06-20</a:t>
             </a:fld>
             <a:endParaRPr lang="ko-KR" altLang="en-US"/>
           </a:p>
@@ -2915,7 +2915,7 @@
           <p:cNvPr id="5" name="바닥글 개체 틀 4">
             <a:extLst>
               <a:ext uri="{FF2B5EF4-FFF2-40B4-BE49-F238E27FC236}">
-                <a16:creationId xmlns:a16="http://schemas.microsoft.com/office/drawing/2014/main" id="{3FE6A4C6-536B-CF6C-AE80-3B8825B16AA3}"/>
+                <a16:creationId xmlns:a16="http://schemas.microsoft.com/office/drawing/2014/main" id="{4DDB46DC-968B-9460-6C38-CCF468D44A26}"/>
               </a:ext>
             </a:extLst>
           </p:cNvPr>
@@ -2958,7 +2958,7 @@
           <p:cNvPr id="6" name="슬라이드 번호 개체 틀 5">
             <a:extLst>
               <a:ext uri="{FF2B5EF4-FFF2-40B4-BE49-F238E27FC236}">
-                <a16:creationId xmlns:a16="http://schemas.microsoft.com/office/drawing/2014/main" id="{3A36A527-F2C3-C4F7-9152-3353B5BB14F2}"/>
+                <a16:creationId xmlns:a16="http://schemas.microsoft.com/office/drawing/2014/main" id="{1ABC2998-23BA-44F9-0E3D-0C0836EA0D08}"/>
               </a:ext>
             </a:extLst>
           </p:cNvPr>
@@ -2992,7 +2992,7 @@
             </a:lvl1pPr>
           </a:lstStyle>
           <a:p>
-            <a:fld id="{D1DEAAE1-9523-4F91-9AA1-FE659F1DC52B}" type="slidenum">
+            <a:fld id="{DA293E9B-4C70-475B-B5B5-C6D1CDF11403}" type="slidenum">
               <a:rPr lang="ko-KR" altLang="en-US" smtClean="0"/>
               <a:t>‹#›</a:t>
             </a:fld>
@@ -3003,7 +3003,7 @@
     </p:spTree>
     <p:extLst>
       <p:ext uri="{BB962C8B-B14F-4D97-AF65-F5344CB8AC3E}">
-        <p14:creationId xmlns:p14="http://schemas.microsoft.com/office/powerpoint/2010/main" val="4178311776"/>
+        <p14:creationId xmlns:p14="http://schemas.microsoft.com/office/powerpoint/2010/main" val="2502164091"/>
       </p:ext>
     </p:extLst>
   </p:cSld>
@@ -3326,7 +3326,7 @@
           <p:cNvPr id="3" name="그래픽 2">
             <a:extLst>
               <a:ext uri="{FF2B5EF4-FFF2-40B4-BE49-F238E27FC236}">
-                <a16:creationId xmlns:a16="http://schemas.microsoft.com/office/drawing/2014/main" id="{8666F243-5E7E-E063-7690-285F5A1CFB72}"/>
+                <a16:creationId xmlns:a16="http://schemas.microsoft.com/office/drawing/2014/main" id="{56050E4B-E0AF-AE95-0D65-C4592E7CC234}"/>
               </a:ext>
             </a:extLst>
           </p:cNvPr>
@@ -3360,7 +3360,7 @@
     </p:spTree>
     <p:extLst>
       <p:ext uri="{BB962C8B-B14F-4D97-AF65-F5344CB8AC3E}">
-        <p14:creationId xmlns:p14="http://schemas.microsoft.com/office/powerpoint/2010/main" val="604552231"/>
+        <p14:creationId xmlns:p14="http://schemas.microsoft.com/office/powerpoint/2010/main" val="809978724"/>
       </p:ext>
     </p:extLst>
   </p:cSld>

</xml_diff>